<commit_message>
chore(examples/pptx/animations): rename output to match script
Aligns with the trio convention from 6fb0b9ce (animations.sh →
animations.pptx instead of gen-animations-pptx.pptx).
</commit_message>
<xml_diff>
--- a/examples/ppt/animations.pptx
+++ b/examples/ppt/animations.pptx
@@ -5,12 +5,12 @@
     <p:sldMasterId xmlns:r="http://schemas.openxmlformats.org/officeDocument/2006/relationships" id="2147483648" r:id="rId1"/>
   </p:sldMasterIdLst>
   <p:sldIdLst>
-    <p:sldId id="256" r:id="R1d4340917dd042dd"/>
-    <p:sldId id="257" r:id="R0c7059c162554011"/>
-    <p:sldId id="258" r:id="R9fc68b462b2a4db1"/>
-    <p:sldId id="259" r:id="R96a801cfb410498e"/>
-    <p:sldId id="260" r:id="R93330af4a4344f85"/>
-    <p:sldId id="261" r:id="R7e1fd86455ae4837"/>
+    <p:sldId id="256" r:id="R7c2ff62878e24cbe"/>
+    <p:sldId id="257" r:id="R0c1eaeacf5464855"/>
+    <p:sldId id="258" r:id="Rccd7cc62e42f42d0"/>
+    <p:sldId id="259" r:id="Rb8e44bba4f2c4e36"/>
+    <p:sldId id="260" r:id="R526b5a5c720b4ed1"/>
+    <p:sldId id="261" r:id="Rdb589eb0535e4cfc"/>
   </p:sldIdLst>
   <p:sldSz cx="12192000" cy="6858000"/>
   <p:notesSz cx="6858000" cy="9144000"/>
@@ -62,7 +62,7 @@
           <a:bodyPr xmlns:a="http://schemas.openxmlformats.org/drawingml/2006/main"/>
           <a:lstStyle xmlns:a="http://schemas.openxmlformats.org/drawingml/2006/main"/>
           <a:p xmlns:a="http://schemas.openxmlformats.org/drawingml/2006/main">
-            <a:endParaRPr lang="zh-CN"/>
+            <a:endParaRPr lang="en-US"/>
           </a:p>
         </p:txBody>
       </p:sp>
@@ -86,7 +86,7 @@
           <a:bodyPr xmlns:a="http://schemas.openxmlformats.org/drawingml/2006/main"/>
           <a:lstStyle xmlns:a="http://schemas.openxmlformats.org/drawingml/2006/main"/>
           <a:p xmlns:a="http://schemas.openxmlformats.org/drawingml/2006/main">
-            <a:endParaRPr lang="zh-CN"/>
+            <a:endParaRPr lang="en-US"/>
           </a:p>
         </p:txBody>
       </p:sp>
@@ -125,7 +125,7 @@
           <a:bodyPr xmlns:a="http://schemas.openxmlformats.org/drawingml/2006/main"/>
           <a:lstStyle xmlns:a="http://schemas.openxmlformats.org/drawingml/2006/main"/>
           <a:p xmlns:a="http://schemas.openxmlformats.org/drawingml/2006/main">
-            <a:endParaRPr lang="zh-CN"/>
+            <a:endParaRPr lang="en-US"/>
           </a:p>
         </p:txBody>
       </p:sp>
@@ -149,7 +149,7 @@
           <a:bodyPr xmlns:a="http://schemas.openxmlformats.org/drawingml/2006/main"/>
           <a:lstStyle xmlns:a="http://schemas.openxmlformats.org/drawingml/2006/main"/>
           <a:p xmlns:a="http://schemas.openxmlformats.org/drawingml/2006/main">
-            <a:endParaRPr lang="zh-CN"/>
+            <a:endParaRPr lang="en-US"/>
           </a:p>
         </p:txBody>
       </p:sp>
@@ -188,7 +188,7 @@
           <a:bodyPr xmlns:a="http://schemas.openxmlformats.org/drawingml/2006/main"/>
           <a:lstStyle xmlns:a="http://schemas.openxmlformats.org/drawingml/2006/main"/>
           <a:p xmlns:a="http://schemas.openxmlformats.org/drawingml/2006/main">
-            <a:endParaRPr lang="zh-CN"/>
+            <a:endParaRPr lang="en-US"/>
           </a:p>
         </p:txBody>
       </p:sp>
@@ -212,7 +212,7 @@
           <a:bodyPr xmlns:a="http://schemas.openxmlformats.org/drawingml/2006/main"/>
           <a:lstStyle xmlns:a="http://schemas.openxmlformats.org/drawingml/2006/main"/>
           <a:p xmlns:a="http://schemas.openxmlformats.org/drawingml/2006/main">
-            <a:endParaRPr lang="zh-CN"/>
+            <a:endParaRPr lang="en-US"/>
           </a:p>
         </p:txBody>
       </p:sp>
@@ -236,7 +236,46 @@
           <a:bodyPr xmlns:a="http://schemas.openxmlformats.org/drawingml/2006/main"/>
           <a:lstStyle xmlns:a="http://schemas.openxmlformats.org/drawingml/2006/main"/>
           <a:p xmlns:a="http://schemas.openxmlformats.org/drawingml/2006/main">
-            <a:endParaRPr lang="zh-CN"/>
+            <a:endParaRPr lang="en-US"/>
+          </a:p>
+        </p:txBody>
+      </p:sp>
+    </p:spTree>
+  </p:cSld>
+</p:sldLayout>
+</file>
+
+<file path=ppt/slideLayouts/slideLayout5.xml><?xml version="1.0" encoding="utf-8"?>
+<p:sldLayout xmlns:a="http://schemas.openxmlformats.org/drawingml/2006/main" xmlns:p="http://schemas.openxmlformats.org/presentationml/2006/main" type="titleOnly">
+  <p:cSld name="Title Only">
+    <p:spTree>
+      <p:nvGrpSpPr>
+        <p:cNvPr id="1" name=""/>
+        <p:cNvGrpSpPr/>
+        <p:nvPr/>
+      </p:nvGrpSpPr>
+      <p:grpSpPr/>
+      <p:sp>
+        <p:nvSpPr>
+          <p:cNvPr id="2" name="Title"/>
+          <p:cNvSpPr>
+            <a:spLocks xmlns:a="http://schemas.openxmlformats.org/drawingml/2006/main" noGrp="1"/>
+          </p:cNvSpPr>
+          <p:nvPr>
+            <p:ph type="title"/>
+          </p:nvPr>
+        </p:nvSpPr>
+        <p:spPr>
+          <a:xfrm xmlns:a="http://schemas.openxmlformats.org/drawingml/2006/main">
+            <a:off x="838200" y="365125"/>
+            <a:ext cx="10515600" cy="1325563"/>
+          </a:xfrm>
+        </p:spPr>
+        <p:txBody>
+          <a:bodyPr xmlns:a="http://schemas.openxmlformats.org/drawingml/2006/main"/>
+          <a:lstStyle xmlns:a="http://schemas.openxmlformats.org/drawingml/2006/main"/>
+          <a:p xmlns:a="http://schemas.openxmlformats.org/drawingml/2006/main">
+            <a:endParaRPr lang="en-US"/>
           </a:p>
         </p:txBody>
       </p:sp>
@@ -263,6 +302,7 @@
     <p:sldLayoutId xmlns:r="http://schemas.openxmlformats.org/officeDocument/2006/relationships" id="2147483650" r:id="rId2"/>
     <p:sldLayoutId xmlns:r="http://schemas.openxmlformats.org/officeDocument/2006/relationships" id="2147483651" r:id="rId3"/>
     <p:sldLayoutId xmlns:r="http://schemas.openxmlformats.org/officeDocument/2006/relationships" id="2147483652" r:id="rId4"/>
+    <p:sldLayoutId xmlns:r="http://schemas.openxmlformats.org/officeDocument/2006/relationships" id="2147483653" r:id="rId5"/>
   </p:sldLayoutIdLst>
 </p:sldMaster>
 </file>
@@ -315,6 +355,11 @@
           <a:lstStyle xmlns:a="http://schemas.openxmlformats.org/drawingml/2006/main"/>
           <a:p xmlns:a="http://schemas.openxmlformats.org/drawingml/2006/main">
             <a:r>
+              <a:rPr sz="4800">
+                <a:solidFill>
+                  <a:srgbClr val="FFFFFF"/>
+                </a:solidFill>
+              </a:rPr>
               <a:t>Animation Showcase</a:t>
             </a:r>
           </a:p>
@@ -341,6 +386,11 @@
           <a:lstStyle xmlns:a="http://schemas.openxmlformats.org/drawingml/2006/main"/>
           <a:p xmlns:a="http://schemas.openxmlformats.org/drawingml/2006/main">
             <a:r>
+              <a:rPr sz="2200">
+                <a:solidFill>
+                  <a:srgbClr val="85C1E9"/>
+                </a:solidFill>
+              </a:rPr>
               <a:t>Every animation effect in officecli</a:t>
             </a:r>
           </a:p>
@@ -373,7 +423,7 @@
       <p:grpSpPr/>
       <p:sp>
         <p:nvSpPr>
-          <p:cNvPr id="1" name="Title"/>
+          <p:cNvPr id="2" name="Title"/>
           <p:cNvSpPr/>
           <p:nvPr>
             <p:ph type="title"/>
@@ -390,7 +440,7 @@
           <a:lstStyle xmlns:a="http://schemas.openxmlformats.org/drawingml/2006/main"/>
           <a:p xmlns:a="http://schemas.openxmlformats.org/drawingml/2006/main">
             <a:r>
-              <a:rPr lang="zh-CN" sz="2800">
+              <a:rPr lang="en-US" sz="2800">
                 <a:solidFill>
                   <a:srgbClr val="FFFFFF"/>
                 </a:solidFill>
@@ -402,11 +452,9 @@
       </p:sp>
       <p:sp>
         <p:nvSpPr>
-          <p:cNvPr id="3" name="TextBox 2"/>
-          <p:cNvSpPr/>
-          <p:nvPr>
-            <p:ph/>
-          </p:nvPr>
+          <p:cNvPr id="10000" name="TextBox 2"/>
+          <p:cNvSpPr/>
+          <p:nvPr/>
         </p:nvSpPr>
         <p:spPr>
           <a:xfrm xmlns:a="http://schemas.openxmlformats.org/drawingml/2006/main">
@@ -425,7 +473,7 @@
           <a:lstStyle xmlns:a="http://schemas.openxmlformats.org/drawingml/2006/main"/>
           <a:p xmlns:a="http://schemas.openxmlformats.org/drawingml/2006/main">
             <a:r>
-              <a:rPr lang="zh-CN" sz="1400">
+              <a:rPr lang="en-US" sz="1400">
                 <a:solidFill>
                   <a:srgbClr val="FFFFFF"/>
                 </a:solidFill>
@@ -439,11 +487,9 @@
       </p:sp>
       <p:sp>
         <p:nvSpPr>
-          <p:cNvPr id="4" name="TextBox 3"/>
-          <p:cNvSpPr/>
-          <p:nvPr>
-            <p:ph/>
-          </p:nvPr>
+          <p:cNvPr id="10001" name="TextBox 3"/>
+          <p:cNvSpPr/>
+          <p:nvPr/>
         </p:nvSpPr>
         <p:spPr>
           <a:xfrm xmlns:a="http://schemas.openxmlformats.org/drawingml/2006/main">
@@ -462,7 +508,7 @@
           <a:lstStyle xmlns:a="http://schemas.openxmlformats.org/drawingml/2006/main"/>
           <a:p xmlns:a="http://schemas.openxmlformats.org/drawingml/2006/main">
             <a:r>
-              <a:rPr lang="zh-CN" sz="1400">
+              <a:rPr lang="en-US" sz="1400">
                 <a:solidFill>
                   <a:srgbClr val="FFFFFF"/>
                 </a:solidFill>
@@ -476,11 +522,9 @@
       </p:sp>
       <p:sp>
         <p:nvSpPr>
-          <p:cNvPr id="5" name="TextBox 4"/>
-          <p:cNvSpPr/>
-          <p:nvPr>
-            <p:ph/>
-          </p:nvPr>
+          <p:cNvPr id="10002" name="TextBox 4"/>
+          <p:cNvSpPr/>
+          <p:nvPr/>
         </p:nvSpPr>
         <p:spPr>
           <a:xfrm xmlns:a="http://schemas.openxmlformats.org/drawingml/2006/main">
@@ -499,7 +543,7 @@
           <a:lstStyle xmlns:a="http://schemas.openxmlformats.org/drawingml/2006/main"/>
           <a:p xmlns:a="http://schemas.openxmlformats.org/drawingml/2006/main">
             <a:r>
-              <a:rPr lang="zh-CN" sz="1400">
+              <a:rPr lang="en-US" sz="1400">
                 <a:solidFill>
                   <a:srgbClr val="FFFFFF"/>
                 </a:solidFill>
@@ -513,11 +557,9 @@
       </p:sp>
       <p:sp>
         <p:nvSpPr>
-          <p:cNvPr id="6" name="TextBox 5"/>
-          <p:cNvSpPr/>
-          <p:nvPr>
-            <p:ph/>
-          </p:nvPr>
+          <p:cNvPr id="10003" name="TextBox 5"/>
+          <p:cNvSpPr/>
+          <p:nvPr/>
         </p:nvSpPr>
         <p:spPr>
           <a:xfrm xmlns:a="http://schemas.openxmlformats.org/drawingml/2006/main">
@@ -536,7 +578,7 @@
           <a:lstStyle xmlns:a="http://schemas.openxmlformats.org/drawingml/2006/main"/>
           <a:p xmlns:a="http://schemas.openxmlformats.org/drawingml/2006/main">
             <a:r>
-              <a:rPr lang="zh-CN" sz="1400">
+              <a:rPr lang="en-US" sz="1400">
                 <a:solidFill>
                   <a:srgbClr val="FFFFFF"/>
                 </a:solidFill>
@@ -550,11 +592,9 @@
       </p:sp>
       <p:sp>
         <p:nvSpPr>
-          <p:cNvPr id="7" name="TextBox 6"/>
-          <p:cNvSpPr/>
-          <p:nvPr>
-            <p:ph/>
-          </p:nvPr>
+          <p:cNvPr id="10004" name="TextBox 6"/>
+          <p:cNvSpPr/>
+          <p:nvPr/>
         </p:nvSpPr>
         <p:spPr>
           <a:xfrm xmlns:a="http://schemas.openxmlformats.org/drawingml/2006/main">
@@ -573,7 +613,7 @@
           <a:lstStyle xmlns:a="http://schemas.openxmlformats.org/drawingml/2006/main"/>
           <a:p xmlns:a="http://schemas.openxmlformats.org/drawingml/2006/main">
             <a:r>
-              <a:rPr lang="zh-CN" sz="1400">
+              <a:rPr lang="en-US" sz="1400">
                 <a:solidFill>
                   <a:srgbClr val="FFFFFF"/>
                 </a:solidFill>
@@ -587,11 +627,9 @@
       </p:sp>
       <p:sp>
         <p:nvSpPr>
-          <p:cNvPr id="8" name="TextBox 7"/>
-          <p:cNvSpPr/>
-          <p:nvPr>
-            <p:ph/>
-          </p:nvPr>
+          <p:cNvPr id="10005" name="TextBox 7"/>
+          <p:cNvSpPr/>
+          <p:nvPr/>
         </p:nvSpPr>
         <p:spPr>
           <a:xfrm xmlns:a="http://schemas.openxmlformats.org/drawingml/2006/main">
@@ -610,7 +648,7 @@
           <a:lstStyle xmlns:a="http://schemas.openxmlformats.org/drawingml/2006/main"/>
           <a:p xmlns:a="http://schemas.openxmlformats.org/drawingml/2006/main">
             <a:r>
-              <a:rPr lang="zh-CN" sz="1400">
+              <a:rPr lang="en-US" sz="1400">
                 <a:solidFill>
                   <a:srgbClr val="FFFFFF"/>
                 </a:solidFill>
@@ -624,11 +662,9 @@
       </p:sp>
       <p:sp>
         <p:nvSpPr>
-          <p:cNvPr id="9" name="TextBox 8"/>
-          <p:cNvSpPr/>
-          <p:nvPr>
-            <p:ph/>
-          </p:nvPr>
+          <p:cNvPr id="10006" name="TextBox 8"/>
+          <p:cNvSpPr/>
+          <p:nvPr/>
         </p:nvSpPr>
         <p:spPr>
           <a:xfrm xmlns:a="http://schemas.openxmlformats.org/drawingml/2006/main">
@@ -647,7 +683,7 @@
           <a:lstStyle xmlns:a="http://schemas.openxmlformats.org/drawingml/2006/main"/>
           <a:p xmlns:a="http://schemas.openxmlformats.org/drawingml/2006/main">
             <a:r>
-              <a:rPr lang="zh-CN" sz="1400">
+              <a:rPr lang="en-US" sz="1400">
                 <a:solidFill>
                   <a:srgbClr val="FFFFFF"/>
                 </a:solidFill>
@@ -661,11 +697,9 @@
       </p:sp>
       <p:sp>
         <p:nvSpPr>
-          <p:cNvPr id="10" name="TextBox 9"/>
-          <p:cNvSpPr/>
-          <p:nvPr>
-            <p:ph/>
-          </p:nvPr>
+          <p:cNvPr id="10007" name="TextBox 9"/>
+          <p:cNvSpPr/>
+          <p:nvPr/>
         </p:nvSpPr>
         <p:spPr>
           <a:xfrm xmlns:a="http://schemas.openxmlformats.org/drawingml/2006/main">
@@ -684,7 +718,7 @@
           <a:lstStyle xmlns:a="http://schemas.openxmlformats.org/drawingml/2006/main"/>
           <a:p xmlns:a="http://schemas.openxmlformats.org/drawingml/2006/main">
             <a:r>
-              <a:rPr lang="zh-CN" sz="1400">
+              <a:rPr lang="en-US" sz="1400">
                 <a:solidFill>
                   <a:srgbClr val="FFFFFF"/>
                 </a:solidFill>
@@ -698,11 +732,9 @@
       </p:sp>
       <p:sp>
         <p:nvSpPr>
-          <p:cNvPr id="11" name="TextBox 10"/>
-          <p:cNvSpPr/>
-          <p:nvPr>
-            <p:ph/>
-          </p:nvPr>
+          <p:cNvPr id="10008" name="TextBox 10"/>
+          <p:cNvSpPr/>
+          <p:nvPr/>
         </p:nvSpPr>
         <p:spPr>
           <a:xfrm xmlns:a="http://schemas.openxmlformats.org/drawingml/2006/main">
@@ -721,7 +753,7 @@
           <a:lstStyle xmlns:a="http://schemas.openxmlformats.org/drawingml/2006/main"/>
           <a:p xmlns:a="http://schemas.openxmlformats.org/drawingml/2006/main">
             <a:r>
-              <a:rPr lang="zh-CN" sz="1400">
+              <a:rPr lang="en-US" sz="1400">
                 <a:solidFill>
                   <a:srgbClr val="FFFFFF"/>
                 </a:solidFill>
@@ -735,11 +767,9 @@
       </p:sp>
       <p:sp>
         <p:nvSpPr>
-          <p:cNvPr id="12" name="TextBox 11"/>
-          <p:cNvSpPr/>
-          <p:nvPr>
-            <p:ph/>
-          </p:nvPr>
+          <p:cNvPr id="10009" name="TextBox 11"/>
+          <p:cNvSpPr/>
+          <p:nvPr/>
         </p:nvSpPr>
         <p:spPr>
           <a:xfrm xmlns:a="http://schemas.openxmlformats.org/drawingml/2006/main">
@@ -758,7 +788,7 @@
           <a:lstStyle xmlns:a="http://schemas.openxmlformats.org/drawingml/2006/main"/>
           <a:p xmlns:a="http://schemas.openxmlformats.org/drawingml/2006/main">
             <a:r>
-              <a:rPr lang="zh-CN" sz="1400">
+              <a:rPr lang="en-US" sz="1400">
                 <a:solidFill>
                   <a:srgbClr val="FFFFFF"/>
                 </a:solidFill>
@@ -772,11 +802,9 @@
       </p:sp>
       <p:sp>
         <p:nvSpPr>
-          <p:cNvPr id="13" name="TextBox 12"/>
-          <p:cNvSpPr/>
-          <p:nvPr>
-            <p:ph/>
-          </p:nvPr>
+          <p:cNvPr id="10010" name="TextBox 12"/>
+          <p:cNvSpPr/>
+          <p:nvPr/>
         </p:nvSpPr>
         <p:spPr>
           <a:xfrm xmlns:a="http://schemas.openxmlformats.org/drawingml/2006/main">
@@ -795,7 +823,7 @@
           <a:lstStyle xmlns:a="http://schemas.openxmlformats.org/drawingml/2006/main"/>
           <a:p xmlns:a="http://schemas.openxmlformats.org/drawingml/2006/main">
             <a:r>
-              <a:rPr lang="zh-CN" sz="1200">
+              <a:rPr lang="en-US" sz="1200">
                 <a:solidFill>
                   <a:srgbClr val="FFFFFF"/>
                 </a:solidFill>
@@ -809,11 +837,9 @@
       </p:sp>
       <p:sp>
         <p:nvSpPr>
-          <p:cNvPr id="14" name="TextBox 13"/>
-          <p:cNvSpPr/>
-          <p:nvPr>
-            <p:ph/>
-          </p:nvPr>
+          <p:cNvPr id="10011" name="TextBox 13"/>
+          <p:cNvSpPr/>
+          <p:nvPr/>
         </p:nvSpPr>
         <p:spPr>
           <a:xfrm xmlns:a="http://schemas.openxmlformats.org/drawingml/2006/main">
@@ -832,7 +858,7 @@
           <a:lstStyle xmlns:a="http://schemas.openxmlformats.org/drawingml/2006/main"/>
           <a:p xmlns:a="http://schemas.openxmlformats.org/drawingml/2006/main">
             <a:r>
-              <a:rPr lang="zh-CN" sz="1400">
+              <a:rPr lang="en-US" sz="1400">
                 <a:solidFill>
                   <a:srgbClr val="FFFFFF"/>
                 </a:solidFill>
@@ -870,7 +896,7 @@
                             </p:stCondLst>
                             <p:childTnLst>
                               <p:par>
-                                <p:cTn id="3" presetID="1" presetClass="entr" presetSubtype="0" fill="hold" grpId="0" nodeType="clickEffect">
+                                <p:cTn id="3" presetID="1" presetClass="entr" presetSubtype="0" dur="500" fill="hold" grpId="0" nodeType="clickEffect">
                                   <p:stCondLst>
                                     <p:cond delay="0"/>
                                   </p:stCondLst>
@@ -883,7 +909,7 @@
                                           </p:stCondLst>
                                         </p:cTn>
                                         <p:tgtEl>
-                                          <p:spTgt spid="3"/>
+                                          <p:spTgt spid="10000"/>
                                         </p:tgtEl>
                                         <p:attrNameLst>
                                           <p:attrName>style.visibility</p:attrName>
@@ -905,7 +931,7 @@
                   <p:par>
                     <p:cTn id="14" fill="hold">
                       <p:stCondLst>
-                        <p:cond delay="indefinite"/>
+                        <p:cond delay="0"/>
                       </p:stCondLst>
                       <p:childTnLst>
                         <p:par>
@@ -915,7 +941,7 @@
                             </p:stCondLst>
                             <p:childTnLst>
                               <p:par>
-                                <p:cTn id="9" presetID="10" presetClass="entr" presetSubtype="0" fill="hold" grpId="1" nodeType="clickEffect">
+                                <p:cTn id="9" presetID="10" presetClass="entr" presetSubtype="0" fill="hold" grpId="1" nodeType="afterEffect">
                                   <p:stCondLst>
                                     <p:cond delay="0"/>
                                   </p:stCondLst>
@@ -928,7 +954,7 @@
                                           </p:stCondLst>
                                         </p:cTn>
                                         <p:tgtEl>
-                                          <p:spTgt spid="4"/>
+                                          <p:spTgt spid="10001"/>
                                         </p:tgtEl>
                                         <p:attrNameLst>
                                           <p:attrName>style.visibility</p:attrName>
@@ -942,7 +968,7 @@
                                       <p:cBhvr>
                                         <p:cTn id="11" dur="800"/>
                                         <p:tgtEl>
-                                          <p:spTgt spid="4"/>
+                                          <p:spTgt spid="10001"/>
                                         </p:tgtEl>
                                       </p:cBhvr>
                                     </p:animEffect>
@@ -956,19 +982,19 @@
                     </p:cTn>
                   </p:par>
                   <p:par>
-                    <p:cTn id="20" fill="hold">
+                    <p:cTn id="21" fill="hold">
                       <p:stCondLst>
-                        <p:cond delay="indefinite"/>
+                        <p:cond delay="0"/>
                       </p:stCondLst>
                       <p:childTnLst>
                         <p:par>
-                          <p:cTn id="19" fill="hold">
+                          <p:cTn id="20" fill="hold">
                             <p:stCondLst>
                               <p:cond delay="0"/>
                             </p:stCondLst>
                             <p:childTnLst>
                               <p:par>
-                                <p:cTn id="15" presetID="2" presetClass="entr" presetSubtype="0" fill="hold" grpId="2" nodeType="clickEffect">
+                                <p:cTn id="15" presetID="2" presetClass="entr" presetSubtype="4" fill="hold" grpId="2" nodeType="afterEffect">
                                   <p:stCondLst>
                                     <p:cond delay="0"/>
                                   </p:stCondLst>
@@ -981,7 +1007,7 @@
                                           </p:stCondLst>
                                         </p:cTn>
                                         <p:tgtEl>
-                                          <p:spTgt spid="5"/>
+                                          <p:spTgt spid="10002"/>
                                         </p:tgtEl>
                                         <p:attrNameLst>
                                           <p:attrName>style.visibility</p:attrName>
@@ -991,11 +1017,134 @@
                                         <p:strVal val="visible"/>
                                       </p:to>
                                     </p:set>
-                                    <p:animEffect transition="in" filter="fly">
-                                      <p:cBhvr>
-                                        <p:cTn id="17" dur="600"/>
-                                        <p:tgtEl>
-                                          <p:spTgt spid="5"/>
+                                    <p:anim calcmode="lin" valueType="num">
+                                      <p:cBhvr additive="base">
+                                        <p:cTn id="19" dur="600" fill="hold"/>
+                                        <p:tgtEl>
+                                          <p:spTgt spid="10002"/>
+                                        </p:tgtEl>
+                                        <p:attrNameLst>
+                                          <p:attrName>ppt_y</p:attrName>
+                                        </p:attrNameLst>
+                                      </p:cBhvr>
+                                      <p:tavLst>
+                                        <p:tav tm="0">
+                                          <p:val>
+                                            <p:strVal val="1+#ppt_h/2"/>
+                                          </p:val>
+                                        </p:tav>
+                                        <p:tav tm="100000">
+                                          <p:val>
+                                            <p:strVal val="#ppt_y"/>
+                                          </p:val>
+                                        </p:tav>
+                                      </p:tavLst>
+                                    </p:anim>
+                                  </p:childTnLst>
+                                </p:cTn>
+                              </p:par>
+                            </p:childTnLst>
+                          </p:cTn>
+                        </p:par>
+                      </p:childTnLst>
+                    </p:cTn>
+                  </p:par>
+                  <p:par>
+                    <p:cTn id="27" fill="hold">
+                      <p:stCondLst>
+                        <p:cond delay="0"/>
+                      </p:stCondLst>
+                      <p:childTnLst>
+                        <p:par>
+                          <p:cTn id="26" fill="hold">
+                            <p:stCondLst>
+                              <p:cond delay="0"/>
+                            </p:stCondLst>
+                            <p:childTnLst>
+                              <p:par>
+                                <p:cTn id="22" presetID="21" presetClass="entr" presetSubtype="0" fill="hold" grpId="3" nodeType="afterEffect">
+                                  <p:stCondLst>
+                                    <p:cond delay="0"/>
+                                  </p:stCondLst>
+                                  <p:childTnLst>
+                                    <p:set>
+                                      <p:cBhvr>
+                                        <p:cTn id="23" dur="1" fill="hold">
+                                          <p:stCondLst>
+                                            <p:cond delay="0"/>
+                                          </p:stCondLst>
+                                        </p:cTn>
+                                        <p:tgtEl>
+                                          <p:spTgt spid="10003"/>
+                                        </p:tgtEl>
+                                        <p:attrNameLst>
+                                          <p:attrName>style.visibility</p:attrName>
+                                        </p:attrNameLst>
+                                      </p:cBhvr>
+                                      <p:to>
+                                        <p:strVal val="visible"/>
+                                      </p:to>
+                                    </p:set>
+                                    <p:animScale zoomContents="1">
+                                      <p:cBhvr>
+                                        <p:cTn id="24" dur="700" fill="hold"/>
+                                        <p:tgtEl>
+                                          <p:spTgt spid="10003"/>
+                                        </p:tgtEl>
+                                      </p:cBhvr>
+                                      <p:from x="0" y="0"/>
+                                      <p:to x="100000" y="100000"/>
+                                    </p:animScale>
+                                  </p:childTnLst>
+                                </p:cTn>
+                              </p:par>
+                            </p:childTnLst>
+                          </p:cTn>
+                        </p:par>
+                      </p:childTnLst>
+                    </p:cTn>
+                  </p:par>
+                  <p:par>
+                    <p:cTn id="33" fill="hold">
+                      <p:stCondLst>
+                        <p:cond delay="0"/>
+                      </p:stCondLst>
+                      <p:childTnLst>
+                        <p:par>
+                          <p:cTn id="32" fill="hold">
+                            <p:stCondLst>
+                              <p:cond delay="0"/>
+                            </p:stCondLst>
+                            <p:childTnLst>
+                              <p:par>
+                                <p:cTn id="28" presetID="20" presetClass="entr" presetSubtype="1" fill="hold" grpId="4" nodeType="afterEffect">
+                                  <p:stCondLst>
+                                    <p:cond delay="0"/>
+                                  </p:stCondLst>
+                                  <p:childTnLst>
+                                    <p:set>
+                                      <p:cBhvr>
+                                        <p:cTn id="29" dur="1" fill="hold">
+                                          <p:stCondLst>
+                                            <p:cond delay="0"/>
+                                          </p:stCondLst>
+                                        </p:cTn>
+                                        <p:tgtEl>
+                                          <p:spTgt spid="10004"/>
+                                        </p:tgtEl>
+                                        <p:attrNameLst>
+                                          <p:attrName>style.visibility</p:attrName>
+                                        </p:attrNameLst>
+                                      </p:cBhvr>
+                                      <p:to>
+                                        <p:strVal val="visible"/>
+                                      </p:to>
+                                    </p:set>
+                                    <p:animEffect transition="in" filter="wipe(left)">
+                                      <p:cBhvr>
+                                        <p:cTn id="30" dur="600"/>
+                                        <p:tgtEl>
+                                          <p:spTgt spid="10004"/>
                                         </p:tgtEl>
                                       </p:cBhvr>
                                     </p:animEffect>
@@ -1009,32 +1158,32 @@
                     </p:cTn>
                   </p:par>
                   <p:par>
-                    <p:cTn id="26" fill="hold">
+                    <p:cTn id="39" fill="hold">
                       <p:stCondLst>
-                        <p:cond delay="indefinite"/>
+                        <p:cond delay="0"/>
                       </p:stCondLst>
                       <p:childTnLst>
                         <p:par>
-                          <p:cTn id="25" fill="hold">
+                          <p:cTn id="38" fill="hold">
                             <p:stCondLst>
                               <p:cond delay="0"/>
                             </p:stCondLst>
                             <p:childTnLst>
                               <p:par>
-                                <p:cTn id="21" presetID="21" presetClass="entr" presetSubtype="0" fill="hold" grpId="3" nodeType="clickEffect">
+                                <p:cTn id="34" presetID="24" presetClass="entr" presetSubtype="0" dur="800" fill="hold" grpId="5" nodeType="afterEffect">
                                   <p:stCondLst>
                                     <p:cond delay="0"/>
                                   </p:stCondLst>
                                   <p:childTnLst>
                                     <p:set>
                                       <p:cBhvr>
-                                        <p:cTn id="22" dur="1" fill="hold">
+                                        <p:cTn id="35" dur="1" fill="hold">
                                           <p:stCondLst>
                                             <p:cond delay="0"/>
                                           </p:stCondLst>
                                         </p:cTn>
                                         <p:tgtEl>
-                                          <p:spTgt spid="6"/>
+                                          <p:spTgt spid="10005"/>
                                         </p:tgtEl>
                                         <p:attrNameLst>
                                           <p:attrName>style.visibility</p:attrName>
@@ -1044,11 +1193,124 @@
                                         <p:strVal val="visible"/>
                                       </p:to>
                                     </p:set>
-                                    <p:animEffect transition="in" filter="zoom">
-                                      <p:cBhvr>
-                                        <p:cTn id="23" dur="700"/>
-                                        <p:tgtEl>
-                                          <p:spTgt spid="6"/>
+                                  </p:childTnLst>
+                                </p:cTn>
+                              </p:par>
+                            </p:childTnLst>
+                          </p:cTn>
+                        </p:par>
+                      </p:childTnLst>
+                    </p:cTn>
+                  </p:par>
+                  <p:par>
+                    <p:cTn id="46" fill="hold">
+                      <p:stCondLst>
+                        <p:cond delay="0"/>
+                      </p:stCondLst>
+                      <p:childTnLst>
+                        <p:par>
+                          <p:cTn id="45" fill="hold">
+                            <p:stCondLst>
+                              <p:cond delay="0"/>
+                            </p:stCondLst>
+                            <p:childTnLst>
+                              <p:par>
+                                <p:cTn id="40" presetID="12" presetClass="entr" presetSubtype="0" fill="hold" grpId="6" nodeType="afterEffect">
+                                  <p:stCondLst>
+                                    <p:cond delay="0"/>
+                                  </p:stCondLst>
+                                  <p:childTnLst>
+                                    <p:set>
+                                      <p:cBhvr>
+                                        <p:cTn id="41" dur="1" fill="hold">
+                                          <p:stCondLst>
+                                            <p:cond delay="0"/>
+                                          </p:stCondLst>
+                                        </p:cTn>
+                                        <p:tgtEl>
+                                          <p:spTgt spid="10006"/>
+                                        </p:tgtEl>
+                                        <p:attrNameLst>
+                                          <p:attrName>style.visibility</p:attrName>
+                                        </p:attrNameLst>
+                                      </p:cBhvr>
+                                      <p:to>
+                                        <p:strVal val="visible"/>
+                                      </p:to>
+                                    </p:set>
+                                    <p:anim calcmode="lin" valueType="num">
+                                      <p:cBhvr additive="base">
+                                        <p:cTn id="44" dur="700" fill="hold"/>
+                                        <p:tgtEl>
+                                          <p:spTgt spid="10006"/>
+                                        </p:tgtEl>
+                                        <p:attrNameLst>
+                                          <p:attrName>ppt_y</p:attrName>
+                                        </p:attrNameLst>
+                                      </p:cBhvr>
+                                      <p:tavLst>
+                                        <p:tav tm="0">
+                                          <p:val>
+                                            <p:strVal val="1+#ppt_h/2"/>
+                                          </p:val>
+                                        </p:tav>
+                                        <p:tav tm="100000">
+                                          <p:val>
+                                            <p:strVal val="#ppt_y"/>
+                                          </p:val>
+                                        </p:tav>
+                                      </p:tavLst>
+                                    </p:anim>
+                                  </p:childTnLst>
+                                </p:cTn>
+                              </p:par>
+                            </p:childTnLst>
+                          </p:cTn>
+                        </p:par>
+                      </p:childTnLst>
+                    </p:cTn>
+                  </p:par>
+                  <p:par>
+                    <p:cTn id="52" fill="hold">
+                      <p:stCondLst>
+                        <p:cond delay="0"/>
+                      </p:stCondLst>
+                      <p:childTnLst>
+                        <p:par>
+                          <p:cTn id="51" fill="hold">
+                            <p:stCondLst>
+                              <p:cond delay="0"/>
+                            </p:stCondLst>
+                            <p:childTnLst>
+                              <p:par>
+                                <p:cTn id="47" presetID="15" presetClass="entr" presetSubtype="10" fill="hold" grpId="7" nodeType="afterEffect">
+                                  <p:stCondLst>
+                                    <p:cond delay="0"/>
+                                  </p:stCondLst>
+                                  <p:childTnLst>
+                                    <p:set>
+                                      <p:cBhvr>
+                                        <p:cTn id="48" dur="1" fill="hold">
+                                          <p:stCondLst>
+                                            <p:cond delay="0"/>
+                                          </p:stCondLst>
+                                        </p:cTn>
+                                        <p:tgtEl>
+                                          <p:spTgt spid="10007"/>
+                                        </p:tgtEl>
+                                        <p:attrNameLst>
+                                          <p:attrName>style.visibility</p:attrName>
+                                        </p:attrNameLst>
+                                      </p:cBhvr>
+                                      <p:to>
+                                        <p:strVal val="visible"/>
+                                      </p:to>
+                                    </p:set>
+                                    <p:animEffect transition="in" filter="barn(inHorizontal)">
+                                      <p:cBhvr>
+                                        <p:cTn id="49" dur="600"/>
+                                        <p:tgtEl>
+                                          <p:spTgt spid="10007"/>
                                         </p:tgtEl>
                                       </p:cBhvr>
                                     </p:animEffect>
@@ -1062,32 +1324,32 @@
                     </p:cTn>
                   </p:par>
                   <p:par>
-                    <p:cTn id="32" fill="hold">
+                    <p:cTn id="58" fill="hold">
                       <p:stCondLst>
-                        <p:cond delay="indefinite"/>
+                        <p:cond delay="0"/>
                       </p:stCondLst>
                       <p:childTnLst>
                         <p:par>
-                          <p:cTn id="31" fill="hold">
+                          <p:cTn id="57" fill="hold">
                             <p:stCondLst>
                               <p:cond delay="0"/>
                             </p:stCondLst>
                             <p:childTnLst>
                               <p:par>
-                                <p:cTn id="27" presetID="20" presetClass="entr" presetSubtype="0" fill="hold" grpId="4" nodeType="clickEffect">
+                                <p:cTn id="53" presetID="19" presetClass="entr" presetSubtype="1" fill="hold" grpId="8" nodeType="afterEffect">
                                   <p:stCondLst>
                                     <p:cond delay="0"/>
                                   </p:stCondLst>
                                   <p:childTnLst>
                                     <p:set>
                                       <p:cBhvr>
-                                        <p:cTn id="28" dur="1" fill="hold">
+                                        <p:cTn id="54" dur="1" fill="hold">
                                           <p:stCondLst>
                                             <p:cond delay="0"/>
                                           </p:stCondLst>
                                         </p:cTn>
                                         <p:tgtEl>
-                                          <p:spTgt spid="7"/>
+                                          <p:spTgt spid="10008"/>
                                         </p:tgtEl>
                                         <p:attrNameLst>
                                           <p:attrName>style.visibility</p:attrName>
@@ -1097,11 +1359,11 @@
                                         <p:strVal val="visible"/>
                                       </p:to>
                                     </p:set>
-                                    <p:animEffect transition="in" filter="wipe(left)">
-                                      <p:cBhvr>
-                                        <p:cTn id="29" dur="600"/>
-                                        <p:tgtEl>
-                                          <p:spTgt spid="7"/>
+                                    <p:animEffect transition="in" filter="wheel(1)">
+                                      <p:cBhvr>
+                                        <p:cTn id="55" dur="800"/>
+                                        <p:tgtEl>
+                                          <p:spTgt spid="10008"/>
                                         </p:tgtEl>
                                       </p:cBhvr>
                                     </p:animEffect>
@@ -1115,32 +1377,32 @@
                     </p:cTn>
                   </p:par>
                   <p:par>
-                    <p:cTn id="38" fill="hold">
+                    <p:cTn id="65" fill="hold">
                       <p:stCondLst>
-                        <p:cond delay="indefinite"/>
+                        <p:cond delay="0"/>
                       </p:stCondLst>
                       <p:childTnLst>
                         <p:par>
-                          <p:cTn id="37" fill="hold">
+                          <p:cTn id="64" fill="hold">
                             <p:stCondLst>
                               <p:cond delay="0"/>
                             </p:stCondLst>
                             <p:childTnLst>
                               <p:par>
-                                <p:cTn id="33" presetID="21" presetClass="entr" presetSubtype="0" fill="hold" grpId="5" nodeType="clickEffect">
+                                <p:cTn id="59" presetID="17" presetClass="entr" presetSubtype="0" fill="hold" grpId="9" nodeType="afterEffect">
                                   <p:stCondLst>
                                     <p:cond delay="0"/>
                                   </p:stCondLst>
                                   <p:childTnLst>
                                     <p:set>
                                       <p:cBhvr>
-                                        <p:cTn id="34" dur="1" fill="hold">
+                                        <p:cTn id="60" dur="1" fill="hold">
                                           <p:stCondLst>
                                             <p:cond delay="0"/>
                                           </p:stCondLst>
                                         </p:cTn>
                                         <p:tgtEl>
-                                          <p:spTgt spid="8"/>
+                                          <p:spTgt spid="10009"/>
                                         </p:tgtEl>
                                         <p:attrNameLst>
                                           <p:attrName>style.visibility</p:attrName>
@@ -1150,11 +1412,19 @@
                                         <p:strVal val="visible"/>
                                       </p:to>
                                     </p:set>
-                                    <p:animEffect transition="in" filter="zoom">
-                                      <p:cBhvr>
-                                        <p:cTn id="35" dur="800"/>
-                                        <p:tgtEl>
-                                          <p:spTgt spid="8"/>
+                                    <p:animRot by="21600000">
+                                      <p:cBhvr>
+                                        <p:cTn id="61" dur="700" fill="hold"/>
+                                        <p:tgtEl>
+                                          <p:spTgt spid="10009"/>
+                                        </p:tgtEl>
+                                      </p:cBhvr>
+                                    </p:animRot>
+                                    <p:animEffect transition="in" filter="fade">
+                                      <p:cBhvr>
+                                        <p:cTn id="63" dur="700"/>
+                                        <p:tgtEl>
+                                          <p:spTgt spid="10009"/>
                                         </p:tgtEl>
                                       </p:cBhvr>
                                     </p:animEffect>
@@ -1168,32 +1438,32 @@
                     </p:cTn>
                   </p:par>
                   <p:par>
-                    <p:cTn id="44" fill="hold">
+                    <p:cTn id="71" fill="hold">
                       <p:stCondLst>
-                        <p:cond delay="indefinite"/>
+                        <p:cond delay="0"/>
                       </p:stCondLst>
                       <p:childTnLst>
                         <p:par>
-                          <p:cTn id="43" fill="hold">
+                          <p:cTn id="70" fill="hold">
                             <p:stCondLst>
                               <p:cond delay="0"/>
                             </p:stCondLst>
                             <p:childTnLst>
                               <p:par>
-                                <p:cTn id="39" presetID="12" presetClass="entr" presetSubtype="0" fill="hold" grpId="6" nodeType="clickEffect">
+                                <p:cTn id="66" presetID="5" presetClass="entr" presetSubtype="5" fill="hold" grpId="10" nodeType="afterEffect">
                                   <p:stCondLst>
                                     <p:cond delay="0"/>
                                   </p:stCondLst>
                                   <p:childTnLst>
                                     <p:set>
                                       <p:cBhvr>
-                                        <p:cTn id="40" dur="1" fill="hold">
+                                        <p:cTn id="67" dur="1" fill="hold">
                                           <p:stCondLst>
                                             <p:cond delay="0"/>
                                           </p:stCondLst>
                                         </p:cTn>
                                         <p:tgtEl>
-                                          <p:spTgt spid="9"/>
+                                          <p:spTgt spid="10010"/>
                                         </p:tgtEl>
                                         <p:attrNameLst>
                                           <p:attrName>style.visibility</p:attrName>
@@ -1203,11 +1473,11 @@
                                         <p:strVal val="visible"/>
                                       </p:to>
                                     </p:set>
-                                    <p:animEffect transition="in" filter="fly">
-                                      <p:cBhvr>
-                                        <p:cTn id="41" dur="700"/>
-                                        <p:tgtEl>
-                                          <p:spTgt spid="9"/>
+                                    <p:animEffect transition="in" filter="checkerboard(across)">
+                                      <p:cBhvr>
+                                        <p:cTn id="68" dur="600"/>
+                                        <p:tgtEl>
+                                          <p:spTgt spid="10010"/>
                                         </p:tgtEl>
                                       </p:cBhvr>
                                     </p:animEffect>
@@ -1221,244 +1491,32 @@
                     </p:cTn>
                   </p:par>
                   <p:par>
-                    <p:cTn id="50" fill="hold">
+                    <p:cTn id="77" fill="hold">
                       <p:stCondLst>
-                        <p:cond delay="indefinite"/>
+                        <p:cond delay="0"/>
                       </p:stCondLst>
                       <p:childTnLst>
                         <p:par>
-                          <p:cTn id="49" fill="hold">
+                          <p:cTn id="76" fill="hold">
                             <p:stCondLst>
                               <p:cond delay="0"/>
                             </p:stCondLst>
                             <p:childTnLst>
                               <p:par>
-                                <p:cTn id="45" presetID="15" presetClass="entr" presetSubtype="0" fill="hold" grpId="7" nodeType="clickEffect">
+                                <p:cTn id="72" presetID="3" presetClass="entr" presetSubtype="10" fill="hold" grpId="11" nodeType="afterEffect">
                                   <p:stCondLst>
                                     <p:cond delay="0"/>
                                   </p:stCondLst>
                                   <p:childTnLst>
                                     <p:set>
                                       <p:cBhvr>
-                                        <p:cTn id="46" dur="1" fill="hold">
+                                        <p:cTn id="73" dur="1" fill="hold">
                                           <p:stCondLst>
                                             <p:cond delay="0"/>
                                           </p:stCondLst>
                                         </p:cTn>
                                         <p:tgtEl>
-                                          <p:spTgt spid="10"/>
-                                        </p:tgtEl>
-                                        <p:attrNameLst>
-                                          <p:attrName>style.visibility</p:attrName>
-                                        </p:attrNameLst>
-                                      </p:cBhvr>
-                                      <p:to>
-                                        <p:strVal val="visible"/>
-                                      </p:to>
-                                    </p:set>
-                                    <p:animEffect transition="in" filter="barn(inHorizontal)">
-                                      <p:cBhvr>
-                                        <p:cTn id="47" dur="600"/>
-                                        <p:tgtEl>
-                                          <p:spTgt spid="10"/>
-                                        </p:tgtEl>
-                                      </p:cBhvr>
-                                    </p:animEffect>
-                                  </p:childTnLst>
-                                </p:cTn>
-                              </p:par>
-                            </p:childTnLst>
-                          </p:cTn>
-                        </p:par>
-                      </p:childTnLst>
-                    </p:cTn>
-                  </p:par>
-                  <p:par>
-                    <p:cTn id="56" fill="hold">
-                      <p:stCondLst>
-                        <p:cond delay="indefinite"/>
-                      </p:stCondLst>
-                      <p:childTnLst>
-                        <p:par>
-                          <p:cTn id="55" fill="hold">
-                            <p:stCondLst>
-                              <p:cond delay="0"/>
-                            </p:stCondLst>
-                            <p:childTnLst>
-                              <p:par>
-                                <p:cTn id="51" presetID="19" presetClass="entr" presetSubtype="0" fill="hold" grpId="8" nodeType="clickEffect">
-                                  <p:stCondLst>
-                                    <p:cond delay="0"/>
-                                  </p:stCondLst>
-                                  <p:childTnLst>
-                                    <p:set>
-                                      <p:cBhvr>
-                                        <p:cTn id="52" dur="1" fill="hold">
-                                          <p:stCondLst>
-                                            <p:cond delay="0"/>
-                                          </p:stCondLst>
-                                        </p:cTn>
-                                        <p:tgtEl>
-                                          <p:spTgt spid="11"/>
-                                        </p:tgtEl>
-                                        <p:attrNameLst>
-                                          <p:attrName>style.visibility</p:attrName>
-                                        </p:attrNameLst>
-                                      </p:cBhvr>
-                                      <p:to>
-                                        <p:strVal val="visible"/>
-                                      </p:to>
-                                    </p:set>
-                                    <p:animEffect transition="in" filter="wheel(1)">
-                                      <p:cBhvr>
-                                        <p:cTn id="53" dur="800"/>
-                                        <p:tgtEl>
-                                          <p:spTgt spid="11"/>
-                                        </p:tgtEl>
-                                      </p:cBhvr>
-                                    </p:animEffect>
-                                  </p:childTnLst>
-                                </p:cTn>
-                              </p:par>
-                            </p:childTnLst>
-                          </p:cTn>
-                        </p:par>
-                      </p:childTnLst>
-                    </p:cTn>
-                  </p:par>
-                  <p:par>
-                    <p:cTn id="62" fill="hold">
-                      <p:stCondLst>
-                        <p:cond delay="indefinite"/>
-                      </p:stCondLst>
-                      <p:childTnLst>
-                        <p:par>
-                          <p:cTn id="61" fill="hold">
-                            <p:stCondLst>
-                              <p:cond delay="0"/>
-                            </p:stCondLst>
-                            <p:childTnLst>
-                              <p:par>
-                                <p:cTn id="57" presetID="17" presetClass="entr" presetSubtype="0" fill="hold" grpId="9" nodeType="clickEffect">
-                                  <p:stCondLst>
-                                    <p:cond delay="0"/>
-                                  </p:stCondLst>
-                                  <p:childTnLst>
-                                    <p:set>
-                                      <p:cBhvr>
-                                        <p:cTn id="58" dur="1" fill="hold">
-                                          <p:stCondLst>
-                                            <p:cond delay="0"/>
-                                          </p:stCondLst>
-                                        </p:cTn>
-                                        <p:tgtEl>
-                                          <p:spTgt spid="12"/>
-                                        </p:tgtEl>
-                                        <p:attrNameLst>
-                                          <p:attrName>style.visibility</p:attrName>
-                                        </p:attrNameLst>
-                                      </p:cBhvr>
-                                      <p:to>
-                                        <p:strVal val="visible"/>
-                                      </p:to>
-                                    </p:set>
-                                    <p:animEffect transition="in" filter="swivel">
-                                      <p:cBhvr>
-                                        <p:cTn id="59" dur="700"/>
-                                        <p:tgtEl>
-                                          <p:spTgt spid="12"/>
-                                        </p:tgtEl>
-                                      </p:cBhvr>
-                                    </p:animEffect>
-                                  </p:childTnLst>
-                                </p:cTn>
-                              </p:par>
-                            </p:childTnLst>
-                          </p:cTn>
-                        </p:par>
-                      </p:childTnLst>
-                    </p:cTn>
-                  </p:par>
-                  <p:par>
-                    <p:cTn id="68" fill="hold">
-                      <p:stCondLst>
-                        <p:cond delay="indefinite"/>
-                      </p:stCondLst>
-                      <p:childTnLst>
-                        <p:par>
-                          <p:cTn id="67" fill="hold">
-                            <p:stCondLst>
-                              <p:cond delay="0"/>
-                            </p:stCondLst>
-                            <p:childTnLst>
-                              <p:par>
-                                <p:cTn id="63" presetID="5" presetClass="entr" presetSubtype="0" fill="hold" grpId="10" nodeType="clickEffect">
-                                  <p:stCondLst>
-                                    <p:cond delay="0"/>
-                                  </p:stCondLst>
-                                  <p:childTnLst>
-                                    <p:set>
-                                      <p:cBhvr>
-                                        <p:cTn id="64" dur="1" fill="hold">
-                                          <p:stCondLst>
-                                            <p:cond delay="0"/>
-                                          </p:stCondLst>
-                                        </p:cTn>
-                                        <p:tgtEl>
-                                          <p:spTgt spid="13"/>
-                                        </p:tgtEl>
-                                        <p:attrNameLst>
-                                          <p:attrName>style.visibility</p:attrName>
-                                        </p:attrNameLst>
-                                      </p:cBhvr>
-                                      <p:to>
-                                        <p:strVal val="visible"/>
-                                      </p:to>
-                                    </p:set>
-                                    <p:animEffect transition="in" filter="checkerboard(across)">
-                                      <p:cBhvr>
-                                        <p:cTn id="65" dur="600"/>
-                                        <p:tgtEl>
-                                          <p:spTgt spid="13"/>
-                                        </p:tgtEl>
-                                      </p:cBhvr>
-                                    </p:animEffect>
-                                  </p:childTnLst>
-                                </p:cTn>
-                              </p:par>
-                            </p:childTnLst>
-                          </p:cTn>
-                        </p:par>
-                      </p:childTnLst>
-                    </p:cTn>
-                  </p:par>
-                  <p:par>
-                    <p:cTn id="74" fill="hold">
-                      <p:stCondLst>
-                        <p:cond delay="indefinite"/>
-                      </p:stCondLst>
-                      <p:childTnLst>
-                        <p:par>
-                          <p:cTn id="73" fill="hold">
-                            <p:stCondLst>
-                              <p:cond delay="0"/>
-                            </p:stCondLst>
-                            <p:childTnLst>
-                              <p:par>
-                                <p:cTn id="69" presetID="3" presetClass="entr" presetSubtype="0" fill="hold" grpId="11" nodeType="clickEffect">
-                                  <p:stCondLst>
-                                    <p:cond delay="0"/>
-                                  </p:stCondLst>
-                                  <p:childTnLst>
-                                    <p:set>
-                                      <p:cBhvr>
-                                        <p:cTn id="70" dur="1" fill="hold">
-                                          <p:stCondLst>
-                                            <p:cond delay="0"/>
-                                          </p:stCondLst>
-                                        </p:cTn>
-                                        <p:tgtEl>
-                                          <p:spTgt spid="14"/>
+                                          <p:spTgt spid="10011"/>
                                         </p:tgtEl>
                                         <p:attrNameLst>
                                           <p:attrName>style.visibility</p:attrName>
@@ -1470,9 +1528,9 @@
                                     </p:set>
                                     <p:animEffect transition="in" filter="blinds(horizontal)">
                                       <p:cBhvr>
-                                        <p:cTn id="71" dur="600"/>
-                                        <p:tgtEl>
-                                          <p:spTgt spid="14"/>
+                                        <p:cTn id="74" dur="600"/>
+                                        <p:tgtEl>
+                                          <p:spTgt spid="10011"/>
                                         </p:tgtEl>
                                       </p:cBhvr>
                                     </p:animEffect>
@@ -1507,18 +1565,18 @@
       </p:par>
     </p:tnLst>
     <p:bldLst>
-      <p:bldP spid="3" grpId="0" build="allAtOnce"/>
-      <p:bldP spid="4" grpId="1" build="allAtOnce"/>
-      <p:bldP spid="5" grpId="2" build="allAtOnce"/>
-      <p:bldP spid="6" grpId="3" build="allAtOnce"/>
-      <p:bldP spid="7" grpId="4" build="allAtOnce"/>
-      <p:bldP spid="8" grpId="5" build="allAtOnce"/>
-      <p:bldP spid="9" grpId="6" build="allAtOnce"/>
-      <p:bldP spid="10" grpId="7" build="allAtOnce"/>
-      <p:bldP spid="11" grpId="8" build="allAtOnce"/>
-      <p:bldP spid="12" grpId="9" build="allAtOnce"/>
-      <p:bldP spid="13" grpId="10" build="allAtOnce"/>
-      <p:bldP spid="14" grpId="11" build="allAtOnce"/>
+      <p:bldP spid="10000" grpId="0"/>
+      <p:bldP spid="10001" grpId="1"/>
+      <p:bldP spid="10002" grpId="2"/>
+      <p:bldP spid="10003" grpId="3"/>
+      <p:bldP spid="10004" grpId="4"/>
+      <p:bldP spid="10005" grpId="5"/>
+      <p:bldP spid="10006" grpId="6"/>
+      <p:bldP spid="10007" grpId="7"/>
+      <p:bldP spid="10008" grpId="8"/>
+      <p:bldP spid="10009" grpId="9"/>
+      <p:bldP spid="10010" grpId="10"/>
+      <p:bldP spid="10011" grpId="11"/>
     </p:bldLst>
   </p:timing>
 </p:sld>
@@ -1543,7 +1601,7 @@
       <p:grpSpPr/>
       <p:sp>
         <p:nvSpPr>
-          <p:cNvPr id="1" name="Title"/>
+          <p:cNvPr id="2" name="Title"/>
           <p:cNvSpPr/>
           <p:nvPr>
             <p:ph type="title"/>
@@ -1560,7 +1618,7 @@
           <a:lstStyle xmlns:a="http://schemas.openxmlformats.org/drawingml/2006/main"/>
           <a:p xmlns:a="http://schemas.openxmlformats.org/drawingml/2006/main">
             <a:r>
-              <a:rPr lang="zh-CN" sz="2800">
+              <a:rPr lang="en-US" sz="2800">
                 <a:solidFill>
                   <a:srgbClr val="FFFFFF"/>
                 </a:solidFill>
@@ -1572,11 +1630,9 @@
       </p:sp>
       <p:sp>
         <p:nvSpPr>
-          <p:cNvPr id="3" name="TextBox 2"/>
-          <p:cNvSpPr/>
-          <p:nvPr>
-            <p:ph/>
-          </p:nvPr>
+          <p:cNvPr id="10012" name="TextBox 2"/>
+          <p:cNvSpPr/>
+          <p:nvPr/>
         </p:nvSpPr>
         <p:spPr>
           <a:xfrm xmlns:a="http://schemas.openxmlformats.org/drawingml/2006/main">
@@ -1595,7 +1651,7 @@
           <a:lstStyle xmlns:a="http://schemas.openxmlformats.org/drawingml/2006/main"/>
           <a:p xmlns:a="http://schemas.openxmlformats.org/drawingml/2006/main">
             <a:r>
-              <a:rPr lang="zh-CN" sz="1400">
+              <a:rPr lang="en-US" sz="1400">
                 <a:solidFill>
                   <a:srgbClr val="FFFFFF"/>
                 </a:solidFill>
@@ -1609,11 +1665,9 @@
       </p:sp>
       <p:sp>
         <p:nvSpPr>
-          <p:cNvPr id="4" name="TextBox 3"/>
-          <p:cNvSpPr/>
-          <p:nvPr>
-            <p:ph/>
-          </p:nvPr>
+          <p:cNvPr id="10013" name="TextBox 3"/>
+          <p:cNvSpPr/>
+          <p:nvPr/>
         </p:nvSpPr>
         <p:spPr>
           <a:xfrm xmlns:a="http://schemas.openxmlformats.org/drawingml/2006/main">
@@ -1632,7 +1686,7 @@
           <a:lstStyle xmlns:a="http://schemas.openxmlformats.org/drawingml/2006/main"/>
           <a:p xmlns:a="http://schemas.openxmlformats.org/drawingml/2006/main">
             <a:r>
-              <a:rPr lang="zh-CN" sz="1400">
+              <a:rPr lang="en-US" sz="1400">
                 <a:solidFill>
                   <a:srgbClr val="FFFFFF"/>
                 </a:solidFill>
@@ -1646,11 +1700,9 @@
       </p:sp>
       <p:sp>
         <p:nvSpPr>
-          <p:cNvPr id="5" name="TextBox 4"/>
-          <p:cNvSpPr/>
-          <p:nvPr>
-            <p:ph/>
-          </p:nvPr>
+          <p:cNvPr id="10014" name="TextBox 4"/>
+          <p:cNvSpPr/>
+          <p:nvPr/>
         </p:nvSpPr>
         <p:spPr>
           <a:xfrm xmlns:a="http://schemas.openxmlformats.org/drawingml/2006/main">
@@ -1669,7 +1721,7 @@
           <a:lstStyle xmlns:a="http://schemas.openxmlformats.org/drawingml/2006/main"/>
           <a:p xmlns:a="http://schemas.openxmlformats.org/drawingml/2006/main">
             <a:r>
-              <a:rPr lang="zh-CN" sz="1400">
+              <a:rPr lang="en-US" sz="1400">
                 <a:solidFill>
                   <a:srgbClr val="FFFFFF"/>
                 </a:solidFill>
@@ -1683,11 +1735,9 @@
       </p:sp>
       <p:sp>
         <p:nvSpPr>
-          <p:cNvPr id="6" name="TextBox 5"/>
-          <p:cNvSpPr/>
-          <p:nvPr>
-            <p:ph/>
-          </p:nvPr>
+          <p:cNvPr id="10015" name="TextBox 5"/>
+          <p:cNvSpPr/>
+          <p:nvPr/>
         </p:nvSpPr>
         <p:spPr>
           <a:xfrm xmlns:a="http://schemas.openxmlformats.org/drawingml/2006/main">
@@ -1706,7 +1756,7 @@
           <a:lstStyle xmlns:a="http://schemas.openxmlformats.org/drawingml/2006/main"/>
           <a:p xmlns:a="http://schemas.openxmlformats.org/drawingml/2006/main">
             <a:r>
-              <a:rPr lang="zh-CN" sz="1400">
+              <a:rPr lang="en-US" sz="1400">
                 <a:solidFill>
                   <a:srgbClr val="FFFFFF"/>
                 </a:solidFill>
@@ -1720,11 +1770,9 @@
       </p:sp>
       <p:sp>
         <p:nvSpPr>
-          <p:cNvPr id="7" name="TextBox 6"/>
-          <p:cNvSpPr/>
-          <p:nvPr>
-            <p:ph/>
-          </p:nvPr>
+          <p:cNvPr id="10016" name="TextBox 6"/>
+          <p:cNvSpPr/>
+          <p:nvPr/>
         </p:nvSpPr>
         <p:spPr>
           <a:xfrm xmlns:a="http://schemas.openxmlformats.org/drawingml/2006/main">
@@ -1743,7 +1791,7 @@
           <a:lstStyle xmlns:a="http://schemas.openxmlformats.org/drawingml/2006/main"/>
           <a:p xmlns:a="http://schemas.openxmlformats.org/drawingml/2006/main">
             <a:r>
-              <a:rPr lang="zh-CN" sz="1400">
+              <a:rPr lang="en-US" sz="1400">
                 <a:solidFill>
                   <a:srgbClr val="FFFFFF"/>
                 </a:solidFill>
@@ -1757,11 +1805,9 @@
       </p:sp>
       <p:sp>
         <p:nvSpPr>
-          <p:cNvPr id="8" name="TextBox 7"/>
-          <p:cNvSpPr/>
-          <p:nvPr>
-            <p:ph/>
-          </p:nvPr>
+          <p:cNvPr id="10017" name="TextBox 7"/>
+          <p:cNvSpPr/>
+          <p:nvPr/>
         </p:nvSpPr>
         <p:spPr>
           <a:xfrm xmlns:a="http://schemas.openxmlformats.org/drawingml/2006/main">
@@ -1780,7 +1826,7 @@
           <a:lstStyle xmlns:a="http://schemas.openxmlformats.org/drawingml/2006/main"/>
           <a:p xmlns:a="http://schemas.openxmlformats.org/drawingml/2006/main">
             <a:r>
-              <a:rPr lang="zh-CN" sz="1400">
+              <a:rPr lang="en-US" sz="1400">
                 <a:solidFill>
                   <a:srgbClr val="FFFFFF"/>
                 </a:solidFill>
@@ -1831,7 +1877,7 @@
                                           </p:stCondLst>
                                         </p:cTn>
                                         <p:tgtEl>
-                                          <p:spTgt spid="3"/>
+                                          <p:spTgt spid="10012"/>
                                         </p:tgtEl>
                                         <p:attrNameLst>
                                           <p:attrName>style.visibility</p:attrName>
@@ -1845,7 +1891,7 @@
                                       <p:cBhvr>
                                         <p:cTn id="5" dur="800"/>
                                         <p:tgtEl>
-                                          <p:spTgt spid="3"/>
+                                          <p:spTgt spid="10012"/>
                                         </p:tgtEl>
                                       </p:cBhvr>
                                     </p:animEffect>
@@ -1859,19 +1905,19 @@
                     </p:cTn>
                   </p:par>
                   <p:par>
-                    <p:cTn id="14" fill="hold">
+                    <p:cTn id="15" fill="hold">
                       <p:stCondLst>
-                        <p:cond delay="indefinite"/>
+                        <p:cond delay="0"/>
                       </p:stCondLst>
                       <p:childTnLst>
                         <p:par>
-                          <p:cTn id="13" fill="hold">
+                          <p:cTn id="14" fill="hold">
                             <p:stCondLst>
                               <p:cond delay="0"/>
                             </p:stCondLst>
                             <p:childTnLst>
                               <p:par>
-                                <p:cTn id="9" presetID="2" presetClass="exit" presetSubtype="0" fill="hold" grpId="1" nodeType="clickEffect">
+                                <p:cTn id="9" presetID="2" presetClass="exit" presetSubtype="4" fill="hold" grpId="1" nodeType="afterEffect">
                                   <p:stCondLst>
                                     <p:cond delay="0"/>
                                   </p:stCondLst>
@@ -1884,7 +1930,7 @@
                                           </p:stCondLst>
                                         </p:cTn>
                                         <p:tgtEl>
-                                          <p:spTgt spid="4"/>
+                                          <p:spTgt spid="10013"/>
                                         </p:tgtEl>
                                         <p:attrNameLst>
                                           <p:attrName>style.visibility</p:attrName>
@@ -1894,11 +1940,134 @@
                                         <p:strVal val="hidden"/>
                                       </p:to>
                                     </p:set>
-                                    <p:animEffect transition="out" filter="fly">
-                                      <p:cBhvr>
-                                        <p:cTn id="11" dur="600"/>
-                                        <p:tgtEl>
-                                          <p:spTgt spid="4"/>
+                                    <p:anim calcmode="lin" valueType="num">
+                                      <p:cBhvr additive="base">
+                                        <p:cTn id="13" dur="600" fill="hold"/>
+                                        <p:tgtEl>
+                                          <p:spTgt spid="10013"/>
+                                        </p:tgtEl>
+                                        <p:attrNameLst>
+                                          <p:attrName>ppt_y</p:attrName>
+                                        </p:attrNameLst>
+                                      </p:cBhvr>
+                                      <p:tavLst>
+                                        <p:tav tm="0">
+                                          <p:val>
+                                            <p:strVal val="#ppt_y"/>
+                                          </p:val>
+                                        </p:tav>
+                                        <p:tav tm="100000">
+                                          <p:val>
+                                            <p:strVal val="1+#ppt_h/2"/>
+                                          </p:val>
+                                        </p:tav>
+                                      </p:tavLst>
+                                    </p:anim>
+                                  </p:childTnLst>
+                                </p:cTn>
+                              </p:par>
+                            </p:childTnLst>
+                          </p:cTn>
+                        </p:par>
+                      </p:childTnLst>
+                    </p:cTn>
+                  </p:par>
+                  <p:par>
+                    <p:cTn id="21" fill="hold">
+                      <p:stCondLst>
+                        <p:cond delay="0"/>
+                      </p:stCondLst>
+                      <p:childTnLst>
+                        <p:par>
+                          <p:cTn id="20" fill="hold">
+                            <p:stCondLst>
+                              <p:cond delay="0"/>
+                            </p:stCondLst>
+                            <p:childTnLst>
+                              <p:par>
+                                <p:cTn id="16" presetID="21" presetClass="exit" presetSubtype="0" fill="hold" grpId="2" nodeType="afterEffect">
+                                  <p:stCondLst>
+                                    <p:cond delay="0"/>
+                                  </p:stCondLst>
+                                  <p:childTnLst>
+                                    <p:set>
+                                      <p:cBhvr>
+                                        <p:cTn id="17" dur="1" fill="hold">
+                                          <p:stCondLst>
+                                            <p:cond delay="0"/>
+                                          </p:stCondLst>
+                                        </p:cTn>
+                                        <p:tgtEl>
+                                          <p:spTgt spid="10014"/>
+                                        </p:tgtEl>
+                                        <p:attrNameLst>
+                                          <p:attrName>style.visibility</p:attrName>
+                                        </p:attrNameLst>
+                                      </p:cBhvr>
+                                      <p:to>
+                                        <p:strVal val="hidden"/>
+                                      </p:to>
+                                    </p:set>
+                                    <p:animScale zoomContents="1">
+                                      <p:cBhvr>
+                                        <p:cTn id="18" dur="700" fill="hold"/>
+                                        <p:tgtEl>
+                                          <p:spTgt spid="10014"/>
+                                        </p:tgtEl>
+                                      </p:cBhvr>
+                                      <p:from x="100000" y="100000"/>
+                                      <p:to x="0" y="0"/>
+                                    </p:animScale>
+                                  </p:childTnLst>
+                                </p:cTn>
+                              </p:par>
+                            </p:childTnLst>
+                          </p:cTn>
+                        </p:par>
+                      </p:childTnLst>
+                    </p:cTn>
+                  </p:par>
+                  <p:par>
+                    <p:cTn id="27" fill="hold">
+                      <p:stCondLst>
+                        <p:cond delay="0"/>
+                      </p:stCondLst>
+                      <p:childTnLst>
+                        <p:par>
+                          <p:cTn id="26" fill="hold">
+                            <p:stCondLst>
+                              <p:cond delay="0"/>
+                            </p:stCondLst>
+                            <p:childTnLst>
+                              <p:par>
+                                <p:cTn id="22" presetID="9" presetClass="exit" presetSubtype="0" fill="hold" grpId="3" nodeType="afterEffect">
+                                  <p:stCondLst>
+                                    <p:cond delay="0"/>
+                                  </p:stCondLst>
+                                  <p:childTnLst>
+                                    <p:set>
+                                      <p:cBhvr>
+                                        <p:cTn id="23" dur="1" fill="hold">
+                                          <p:stCondLst>
+                                            <p:cond delay="0"/>
+                                          </p:stCondLst>
+                                        </p:cTn>
+                                        <p:tgtEl>
+                                          <p:spTgt spid="10015"/>
+                                        </p:tgtEl>
+                                        <p:attrNameLst>
+                                          <p:attrName>style.visibility</p:attrName>
+                                        </p:attrNameLst>
+                                      </p:cBhvr>
+                                      <p:to>
+                                        <p:strVal val="hidden"/>
+                                      </p:to>
+                                    </p:set>
+                                    <p:animEffect transition="out" filter="dissolve">
+                                      <p:cBhvr>
+                                        <p:cTn id="24" dur="600"/>
+                                        <p:tgtEl>
+                                          <p:spTgt spid="10015"/>
                                         </p:tgtEl>
                                       </p:cBhvr>
                                     </p:animEffect>
@@ -1912,32 +2081,32 @@
                     </p:cTn>
                   </p:par>
                   <p:par>
-                    <p:cTn id="20" fill="hold">
+                    <p:cTn id="33" fill="hold">
                       <p:stCondLst>
-                        <p:cond delay="indefinite"/>
+                        <p:cond delay="0"/>
                       </p:stCondLst>
                       <p:childTnLst>
                         <p:par>
-                          <p:cTn id="19" fill="hold">
+                          <p:cTn id="32" fill="hold">
                             <p:stCondLst>
                               <p:cond delay="0"/>
                             </p:stCondLst>
                             <p:childTnLst>
                               <p:par>
-                                <p:cTn id="15" presetID="21" presetClass="exit" presetSubtype="0" fill="hold" grpId="2" nodeType="clickEffect">
+                                <p:cTn id="28" presetID="20" presetClass="exit" presetSubtype="1" fill="hold" grpId="4" nodeType="afterEffect">
                                   <p:stCondLst>
                                     <p:cond delay="0"/>
                                   </p:stCondLst>
                                   <p:childTnLst>
                                     <p:set>
                                       <p:cBhvr>
-                                        <p:cTn id="16" dur="1" fill="hold">
+                                        <p:cTn id="29" dur="1" fill="hold">
                                           <p:stCondLst>
                                             <p:cond delay="0"/>
                                           </p:stCondLst>
                                         </p:cTn>
                                         <p:tgtEl>
-                                          <p:spTgt spid="5"/>
+                                          <p:spTgt spid="10016"/>
                                         </p:tgtEl>
                                         <p:attrNameLst>
                                           <p:attrName>style.visibility</p:attrName>
@@ -1947,11 +2116,11 @@
                                         <p:strVal val="hidden"/>
                                       </p:to>
                                     </p:set>
-                                    <p:animEffect transition="out" filter="zoom">
-                                      <p:cBhvr>
-                                        <p:cTn id="17" dur="700"/>
-                                        <p:tgtEl>
-                                          <p:spTgt spid="5"/>
+                                    <p:animEffect transition="out" filter="wipe(left)">
+                                      <p:cBhvr>
+                                        <p:cTn id="30" dur="600"/>
+                                        <p:tgtEl>
+                                          <p:spTgt spid="10016"/>
                                         </p:tgtEl>
                                       </p:cBhvr>
                                     </p:animEffect>
@@ -1965,138 +2134,32 @@
                     </p:cTn>
                   </p:par>
                   <p:par>
-                    <p:cTn id="26" fill="hold">
+                    <p:cTn id="39" fill="hold">
                       <p:stCondLst>
-                        <p:cond delay="indefinite"/>
+                        <p:cond delay="0"/>
                       </p:stCondLst>
                       <p:childTnLst>
                         <p:par>
-                          <p:cTn id="25" fill="hold">
+                          <p:cTn id="38" fill="hold">
                             <p:stCondLst>
                               <p:cond delay="0"/>
                             </p:stCondLst>
                             <p:childTnLst>
                               <p:par>
-                                <p:cTn id="21" presetID="9" presetClass="exit" presetSubtype="0" fill="hold" grpId="3" nodeType="clickEffect">
+                                <p:cTn id="34" presetID="11" presetClass="exit" presetSubtype="0" fill="hold" grpId="5" nodeType="afterEffect">
                                   <p:stCondLst>
                                     <p:cond delay="0"/>
                                   </p:stCondLst>
                                   <p:childTnLst>
                                     <p:set>
                                       <p:cBhvr>
-                                        <p:cTn id="22" dur="1" fill="hold">
+                                        <p:cTn id="35" dur="1" fill="hold">
                                           <p:stCondLst>
                                             <p:cond delay="0"/>
                                           </p:stCondLst>
                                         </p:cTn>
                                         <p:tgtEl>
-                                          <p:spTgt spid="6"/>
-                                        </p:tgtEl>
-                                        <p:attrNameLst>
-                                          <p:attrName>style.visibility</p:attrName>
-                                        </p:attrNameLst>
-                                      </p:cBhvr>
-                                      <p:to>
-                                        <p:strVal val="hidden"/>
-                                      </p:to>
-                                    </p:set>
-                                    <p:animEffect transition="out" filter="dissolve">
-                                      <p:cBhvr>
-                                        <p:cTn id="23" dur="600"/>
-                                        <p:tgtEl>
-                                          <p:spTgt spid="6"/>
-                                        </p:tgtEl>
-                                      </p:cBhvr>
-                                    </p:animEffect>
-                                  </p:childTnLst>
-                                </p:cTn>
-                              </p:par>
-                            </p:childTnLst>
-                          </p:cTn>
-                        </p:par>
-                      </p:childTnLst>
-                    </p:cTn>
-                  </p:par>
-                  <p:par>
-                    <p:cTn id="32" fill="hold">
-                      <p:stCondLst>
-                        <p:cond delay="indefinite"/>
-                      </p:stCondLst>
-                      <p:childTnLst>
-                        <p:par>
-                          <p:cTn id="31" fill="hold">
-                            <p:stCondLst>
-                              <p:cond delay="0"/>
-                            </p:stCondLst>
-                            <p:childTnLst>
-                              <p:par>
-                                <p:cTn id="27" presetID="20" presetClass="exit" presetSubtype="0" fill="hold" grpId="4" nodeType="clickEffect">
-                                  <p:stCondLst>
-                                    <p:cond delay="0"/>
-                                  </p:stCondLst>
-                                  <p:childTnLst>
-                                    <p:set>
-                                      <p:cBhvr>
-                                        <p:cTn id="28" dur="1" fill="hold">
-                                          <p:stCondLst>
-                                            <p:cond delay="0"/>
-                                          </p:stCondLst>
-                                        </p:cTn>
-                                        <p:tgtEl>
-                                          <p:spTgt spid="7"/>
-                                        </p:tgtEl>
-                                        <p:attrNameLst>
-                                          <p:attrName>style.visibility</p:attrName>
-                                        </p:attrNameLst>
-                                      </p:cBhvr>
-                                      <p:to>
-                                        <p:strVal val="hidden"/>
-                                      </p:to>
-                                    </p:set>
-                                    <p:animEffect transition="out" filter="wipe(left)">
-                                      <p:cBhvr>
-                                        <p:cTn id="29" dur="600"/>
-                                        <p:tgtEl>
-                                          <p:spTgt spid="7"/>
-                                        </p:tgtEl>
-                                      </p:cBhvr>
-                                    </p:animEffect>
-                                  </p:childTnLst>
-                                </p:cTn>
-                              </p:par>
-                            </p:childTnLst>
-                          </p:cTn>
-                        </p:par>
-                      </p:childTnLst>
-                    </p:cTn>
-                  </p:par>
-                  <p:par>
-                    <p:cTn id="38" fill="hold">
-                      <p:stCondLst>
-                        <p:cond delay="indefinite"/>
-                      </p:stCondLst>
-                      <p:childTnLst>
-                        <p:par>
-                          <p:cTn id="37" fill="hold">
-                            <p:stCondLst>
-                              <p:cond delay="0"/>
-                            </p:stCondLst>
-                            <p:childTnLst>
-                              <p:par>
-                                <p:cTn id="33" presetID="11" presetClass="exit" presetSubtype="0" fill="hold" grpId="5" nodeType="clickEffect">
-                                  <p:stCondLst>
-                                    <p:cond delay="0"/>
-                                  </p:stCondLst>
-                                  <p:childTnLst>
-                                    <p:set>
-                                      <p:cBhvr>
-                                        <p:cTn id="34" dur="1" fill="hold">
-                                          <p:stCondLst>
-                                            <p:cond delay="0"/>
-                                          </p:stCondLst>
-                                        </p:cTn>
-                                        <p:tgtEl>
-                                          <p:spTgt spid="8"/>
+                                          <p:spTgt spid="10017"/>
                                         </p:tgtEl>
                                         <p:attrNameLst>
                                           <p:attrName>style.visibility</p:attrName>
@@ -2108,9 +2171,9 @@
                                     </p:set>
                                     <p:animEffect transition="out" filter="flash">
                                       <p:cBhvr>
-                                        <p:cTn id="35" dur="500"/>
-                                        <p:tgtEl>
-                                          <p:spTgt spid="8"/>
+                                        <p:cTn id="36" dur="500"/>
+                                        <p:tgtEl>
+                                          <p:spTgt spid="10017"/>
                                         </p:tgtEl>
                                       </p:cBhvr>
                                     </p:animEffect>
@@ -2145,12 +2208,12 @@
       </p:par>
     </p:tnLst>
     <p:bldLst>
-      <p:bldP spid="3" grpId="0" build="allAtOnce"/>
-      <p:bldP spid="4" grpId="1" build="allAtOnce"/>
-      <p:bldP spid="5" grpId="2" build="allAtOnce"/>
-      <p:bldP spid="6" grpId="3" build="allAtOnce"/>
-      <p:bldP spid="7" grpId="4" build="allAtOnce"/>
-      <p:bldP spid="8" grpId="5" build="allAtOnce"/>
+      <p:bldP spid="10012" grpId="0"/>
+      <p:bldP spid="10013" grpId="1"/>
+      <p:bldP spid="10014" grpId="2"/>
+      <p:bldP spid="10015" grpId="3"/>
+      <p:bldP spid="10016" grpId="4"/>
+      <p:bldP spid="10017" grpId="5"/>
     </p:bldLst>
   </p:timing>
 </p:sld>
@@ -2175,7 +2238,7 @@
       <p:grpSpPr/>
       <p:sp>
         <p:nvSpPr>
-          <p:cNvPr id="1" name="Title"/>
+          <p:cNvPr id="2" name="Title"/>
           <p:cNvSpPr/>
           <p:nvPr>
             <p:ph type="title"/>
@@ -2192,7 +2255,7 @@
           <a:lstStyle xmlns:a="http://schemas.openxmlformats.org/drawingml/2006/main"/>
           <a:p xmlns:a="http://schemas.openxmlformats.org/drawingml/2006/main">
             <a:r>
-              <a:rPr lang="zh-CN" sz="2800">
+              <a:rPr lang="en-US" sz="2800">
                 <a:solidFill>
                   <a:srgbClr val="FFFFFF"/>
                 </a:solidFill>
@@ -2204,11 +2267,9 @@
       </p:sp>
       <p:sp>
         <p:nvSpPr>
-          <p:cNvPr id="3" name="TextBox 2"/>
-          <p:cNvSpPr/>
-          <p:nvPr>
-            <p:ph/>
-          </p:nvPr>
+          <p:cNvPr id="10018" name="TextBox 2"/>
+          <p:cNvSpPr/>
+          <p:nvPr/>
         </p:nvSpPr>
         <p:spPr>
           <a:xfrm xmlns:a="http://schemas.openxmlformats.org/drawingml/2006/main">
@@ -2227,7 +2288,7 @@
           <a:lstStyle xmlns:a="http://schemas.openxmlformats.org/drawingml/2006/main"/>
           <a:p xmlns:a="http://schemas.openxmlformats.org/drawingml/2006/main">
             <a:r>
-              <a:rPr lang="zh-CN" sz="1600">
+              <a:rPr lang="en-US" sz="1600">
                 <a:solidFill>
                   <a:srgbClr val="FFFFFF"/>
                 </a:solidFill>
@@ -2241,11 +2302,9 @@
       </p:sp>
       <p:sp>
         <p:nvSpPr>
-          <p:cNvPr id="4" name="TextBox 3"/>
-          <p:cNvSpPr/>
-          <p:nvPr>
-            <p:ph/>
-          </p:nvPr>
+          <p:cNvPr id="10019" name="TextBox 3"/>
+          <p:cNvSpPr/>
+          <p:nvPr/>
         </p:nvSpPr>
         <p:spPr>
           <a:xfrm xmlns:a="http://schemas.openxmlformats.org/drawingml/2006/main">
@@ -2264,7 +2323,7 @@
           <a:lstStyle xmlns:a="http://schemas.openxmlformats.org/drawingml/2006/main"/>
           <a:p xmlns:a="http://schemas.openxmlformats.org/drawingml/2006/main">
             <a:r>
-              <a:rPr lang="zh-CN" sz="1600">
+              <a:rPr lang="en-US" sz="1600">
                 <a:solidFill>
                   <a:srgbClr val="FFFFFF"/>
                 </a:solidFill>
@@ -2278,11 +2337,9 @@
       </p:sp>
       <p:sp>
         <p:nvSpPr>
-          <p:cNvPr id="5" name="TextBox 4"/>
-          <p:cNvSpPr/>
-          <p:nvPr>
-            <p:ph/>
-          </p:nvPr>
+          <p:cNvPr id="10020" name="TextBox 4"/>
+          <p:cNvSpPr/>
+          <p:nvPr/>
         </p:nvSpPr>
         <p:spPr>
           <a:xfrm xmlns:a="http://schemas.openxmlformats.org/drawingml/2006/main">
@@ -2301,7 +2358,7 @@
           <a:lstStyle xmlns:a="http://schemas.openxmlformats.org/drawingml/2006/main"/>
           <a:p xmlns:a="http://schemas.openxmlformats.org/drawingml/2006/main">
             <a:r>
-              <a:rPr lang="zh-CN" sz="1600">
+              <a:rPr lang="en-US" sz="1600">
                 <a:solidFill>
                   <a:srgbClr val="FFFFFF"/>
                 </a:solidFill>
@@ -2315,11 +2372,9 @@
       </p:sp>
       <p:sp>
         <p:nvSpPr>
-          <p:cNvPr id="6" name="TextBox 5"/>
-          <p:cNvSpPr/>
-          <p:nvPr>
-            <p:ph/>
-          </p:nvPr>
+          <p:cNvPr id="10021" name="TextBox 5"/>
+          <p:cNvSpPr/>
+          <p:nvPr/>
         </p:nvSpPr>
         <p:spPr>
           <a:xfrm xmlns:a="http://schemas.openxmlformats.org/drawingml/2006/main">
@@ -2338,7 +2393,7 @@
           <a:lstStyle xmlns:a="http://schemas.openxmlformats.org/drawingml/2006/main"/>
           <a:p xmlns:a="http://schemas.openxmlformats.org/drawingml/2006/main">
             <a:r>
-              <a:rPr lang="zh-CN" sz="1600">
+              <a:rPr lang="en-US" sz="1600">
                 <a:solidFill>
                   <a:srgbClr val="FFFFFF"/>
                 </a:solidFill>
@@ -2376,7 +2431,7 @@
                             </p:stCondLst>
                             <p:childTnLst>
                               <p:par>
-                                <p:cTn id="3" presetID="27" presetClass="emph" presetSubtype="0" fill="hold" grpId="0" nodeType="clickEffect">
+                                <p:cTn id="3" presetID="27" presetClass="emph" presetSubtype="0" dur="1000" fill="hold" grpId="0" nodeType="clickEffect">
                                   <p:stCondLst>
                                     <p:cond delay="0"/>
                                   </p:stCondLst>
@@ -2389,14 +2444,14 @@
                                           </p:stCondLst>
                                         </p:cTn>
                                         <p:tgtEl>
-                                          <p:spTgt spid="3"/>
+                                          <p:spTgt spid="10018"/>
                                         </p:tgtEl>
                                         <p:attrNameLst>
                                           <p:attrName>style.visibility</p:attrName>
                                         </p:attrNameLst>
                                       </p:cBhvr>
                                       <p:to>
-                                        <p:strVal val="hidden"/>
+                                        <p:strVal val="visible"/>
                                       </p:to>
                                     </p:set>
                                   </p:childTnLst>
@@ -2411,7 +2466,7 @@
                   <p:par>
                     <p:cTn id="14" fill="hold">
                       <p:stCondLst>
-                        <p:cond delay="indefinite"/>
+                        <p:cond delay="0"/>
                       </p:stCondLst>
                       <p:childTnLst>
                         <p:par>
@@ -2421,7 +2476,7 @@
                             </p:stCondLst>
                             <p:childTnLst>
                               <p:par>
-                                <p:cTn id="9" presetID="26" presetClass="emph" presetSubtype="0" fill="hold" grpId="1" nodeType="clickEffect">
+                                <p:cTn id="9" presetID="26" presetClass="emph" presetSubtype="0" dur="800" fill="hold" grpId="1" nodeType="afterEffect">
                                   <p:stCondLst>
                                     <p:cond delay="0"/>
                                   </p:stCondLst>
@@ -2434,14 +2489,14 @@
                                           </p:stCondLst>
                                         </p:cTn>
                                         <p:tgtEl>
-                                          <p:spTgt spid="4"/>
+                                          <p:spTgt spid="10019"/>
                                         </p:tgtEl>
                                         <p:attrNameLst>
                                           <p:attrName>style.visibility</p:attrName>
                                         </p:attrNameLst>
                                       </p:cBhvr>
                                       <p:to>
-                                        <p:strVal val="hidden"/>
+                                        <p:strVal val="visible"/>
                                       </p:to>
                                     </p:set>
                                   </p:childTnLst>
@@ -2456,7 +2511,7 @@
                   <p:par>
                     <p:cTn id="20" fill="hold">
                       <p:stCondLst>
-                        <p:cond delay="indefinite"/>
+                        <p:cond delay="0"/>
                       </p:stCondLst>
                       <p:childTnLst>
                         <p:par>
@@ -2466,7 +2521,7 @@
                             </p:stCondLst>
                             <p:childTnLst>
                               <p:par>
-                                <p:cTn id="15" presetID="14" presetClass="emph" presetSubtype="0" fill="hold" grpId="2" nodeType="clickEffect">
+                                <p:cTn id="15" presetID="14" presetClass="emph" presetSubtype="0" dur="700" fill="hold" grpId="2" nodeType="afterEffect">
                                   <p:stCondLst>
                                     <p:cond delay="0"/>
                                   </p:stCondLst>
@@ -2479,14 +2534,14 @@
                                           </p:stCondLst>
                                         </p:cTn>
                                         <p:tgtEl>
-                                          <p:spTgt spid="5"/>
+                                          <p:spTgt spid="10020"/>
                                         </p:tgtEl>
                                         <p:attrNameLst>
                                           <p:attrName>style.visibility</p:attrName>
                                         </p:attrNameLst>
                                       </p:cBhvr>
                                       <p:to>
-                                        <p:strVal val="hidden"/>
+                                        <p:strVal val="visible"/>
                                       </p:to>
                                     </p:set>
                                   </p:childTnLst>
@@ -2501,7 +2556,7 @@
                   <p:par>
                     <p:cTn id="26" fill="hold">
                       <p:stCondLst>
-                        <p:cond delay="indefinite"/>
+                        <p:cond delay="0"/>
                       </p:stCondLst>
                       <p:childTnLst>
                         <p:par>
@@ -2511,7 +2566,7 @@
                             </p:stCondLst>
                             <p:childTnLst>
                               <p:par>
-                                <p:cTn id="21" presetID="1" presetClass="emph" presetSubtype="0" fill="hold" grpId="3" nodeType="clickEffect">
+                                <p:cTn id="21" presetID="1" presetClass="emph" presetSubtype="0" dur="500" fill="hold" grpId="3" nodeType="afterEffect">
                                   <p:stCondLst>
                                     <p:cond delay="0"/>
                                   </p:stCondLst>
@@ -2524,14 +2579,14 @@
                                           </p:stCondLst>
                                         </p:cTn>
                                         <p:tgtEl>
-                                          <p:spTgt spid="6"/>
+                                          <p:spTgt spid="10021"/>
                                         </p:tgtEl>
                                         <p:attrNameLst>
                                           <p:attrName>style.visibility</p:attrName>
                                         </p:attrNameLst>
                                       </p:cBhvr>
                                       <p:to>
-                                        <p:strVal val="hidden"/>
+                                        <p:strVal val="visible"/>
                                       </p:to>
                                     </p:set>
                                   </p:childTnLst>
@@ -2565,10 +2620,10 @@
       </p:par>
     </p:tnLst>
     <p:bldLst>
-      <p:bldP spid="3" grpId="0" build="allAtOnce"/>
-      <p:bldP spid="4" grpId="1" build="allAtOnce"/>
-      <p:bldP spid="5" grpId="2" build="allAtOnce"/>
-      <p:bldP spid="6" grpId="3" build="allAtOnce"/>
+      <p:bldP spid="10018" grpId="0"/>
+      <p:bldP spid="10019" grpId="1"/>
+      <p:bldP spid="10020" grpId="2"/>
+      <p:bldP spid="10021" grpId="3"/>
     </p:bldLst>
   </p:timing>
 </p:sld>
@@ -2593,7 +2648,7 @@
       <p:grpSpPr/>
       <p:sp>
         <p:nvSpPr>
-          <p:cNvPr id="1" name="Title"/>
+          <p:cNvPr id="2" name="Title"/>
           <p:cNvSpPr/>
           <p:nvPr>
             <p:ph type="title"/>
@@ -2610,7 +2665,7 @@
           <a:lstStyle xmlns:a="http://schemas.openxmlformats.org/drawingml/2006/main"/>
           <a:p xmlns:a="http://schemas.openxmlformats.org/drawingml/2006/main">
             <a:r>
-              <a:rPr lang="zh-CN" sz="2800">
+              <a:rPr lang="en-US" sz="2800">
                 <a:solidFill>
                   <a:srgbClr val="FFFFFF"/>
                 </a:solidFill>
@@ -2622,11 +2677,9 @@
       </p:sp>
       <p:sp>
         <p:nvSpPr>
-          <p:cNvPr id="3" name="TextBox 2"/>
-          <p:cNvSpPr/>
-          <p:nvPr>
-            <p:ph/>
-          </p:nvPr>
+          <p:cNvPr id="10022" name="TextBox 2"/>
+          <p:cNvSpPr/>
+          <p:nvPr/>
         </p:nvSpPr>
         <p:spPr>
           <a:xfrm xmlns:a="http://schemas.openxmlformats.org/drawingml/2006/main">
@@ -2650,7 +2703,7 @@
           <a:lstStyle xmlns:a="http://schemas.openxmlformats.org/drawingml/2006/main"/>
           <a:p xmlns:a="http://schemas.openxmlformats.org/drawingml/2006/main">
             <a:r>
-              <a:rPr lang="zh-CN" sz="1200">
+              <a:rPr lang="en-US" sz="1200">
                 <a:solidFill>
                   <a:srgbClr val="FFFFFF"/>
                 </a:solidFill>
@@ -2664,11 +2717,9 @@
       </p:sp>
       <p:sp>
         <p:nvSpPr>
-          <p:cNvPr id="4" name="TextBox 3"/>
-          <p:cNvSpPr/>
-          <p:nvPr>
-            <p:ph/>
-          </p:nvPr>
+          <p:cNvPr id="10023" name="TextBox 3"/>
+          <p:cNvSpPr/>
+          <p:nvPr/>
         </p:nvSpPr>
         <p:spPr>
           <a:xfrm xmlns:a="http://schemas.openxmlformats.org/drawingml/2006/main">
@@ -2692,7 +2743,7 @@
           <a:lstStyle xmlns:a="http://schemas.openxmlformats.org/drawingml/2006/main"/>
           <a:p xmlns:a="http://schemas.openxmlformats.org/drawingml/2006/main">
             <a:r>
-              <a:rPr lang="zh-CN" sz="1200">
+              <a:rPr lang="en-US" sz="1200">
                 <a:solidFill>
                   <a:srgbClr val="FFFFFF"/>
                 </a:solidFill>
@@ -2706,11 +2757,9 @@
       </p:sp>
       <p:sp>
         <p:nvSpPr>
-          <p:cNvPr id="5" name="TextBox 4"/>
-          <p:cNvSpPr/>
-          <p:nvPr>
-            <p:ph/>
-          </p:nvPr>
+          <p:cNvPr id="10024" name="TextBox 4"/>
+          <p:cNvSpPr/>
+          <p:nvPr/>
         </p:nvSpPr>
         <p:spPr>
           <a:xfrm xmlns:a="http://schemas.openxmlformats.org/drawingml/2006/main">
@@ -2734,7 +2783,7 @@
           <a:lstStyle xmlns:a="http://schemas.openxmlformats.org/drawingml/2006/main"/>
           <a:p xmlns:a="http://schemas.openxmlformats.org/drawingml/2006/main">
             <a:r>
-              <a:rPr lang="zh-CN" sz="1200">
+              <a:rPr lang="en-US" sz="1200">
                 <a:solidFill>
                   <a:srgbClr val="FFFFFF"/>
                 </a:solidFill>
@@ -2748,11 +2797,9 @@
       </p:sp>
       <p:sp>
         <p:nvSpPr>
-          <p:cNvPr id="6" name="TextBox 5"/>
-          <p:cNvSpPr/>
-          <p:nvPr>
-            <p:ph/>
-          </p:nvPr>
+          <p:cNvPr id="10025" name="TextBox 5"/>
+          <p:cNvSpPr/>
+          <p:nvPr/>
         </p:nvSpPr>
         <p:spPr>
           <a:xfrm xmlns:a="http://schemas.openxmlformats.org/drawingml/2006/main">
@@ -2776,7 +2823,7 @@
           <a:lstStyle xmlns:a="http://schemas.openxmlformats.org/drawingml/2006/main"/>
           <a:p xmlns:a="http://schemas.openxmlformats.org/drawingml/2006/main">
             <a:r>
-              <a:rPr lang="zh-CN" sz="1200">
+              <a:rPr lang="en-US" sz="1200">
                 <a:solidFill>
                   <a:srgbClr val="FFFFFF"/>
                 </a:solidFill>
@@ -2790,11 +2837,9 @@
       </p:sp>
       <p:sp>
         <p:nvSpPr>
-          <p:cNvPr id="7" name="TextBox 6"/>
-          <p:cNvSpPr/>
-          <p:nvPr>
-            <p:ph/>
-          </p:nvPr>
+          <p:cNvPr id="10026" name="TextBox 6"/>
+          <p:cNvSpPr/>
+          <p:nvPr/>
         </p:nvSpPr>
         <p:spPr>
           <a:xfrm xmlns:a="http://schemas.openxmlformats.org/drawingml/2006/main">
@@ -2818,7 +2863,7 @@
           <a:lstStyle xmlns:a="http://schemas.openxmlformats.org/drawingml/2006/main"/>
           <a:p xmlns:a="http://schemas.openxmlformats.org/drawingml/2006/main">
             <a:r>
-              <a:rPr lang="zh-CN" sz="1200">
+              <a:rPr lang="en-US" sz="1200">
                 <a:solidFill>
                   <a:srgbClr val="FFFFFF"/>
                 </a:solidFill>
@@ -2832,11 +2877,9 @@
       </p:sp>
       <p:sp>
         <p:nvSpPr>
-          <p:cNvPr id="8" name="TextBox 7"/>
-          <p:cNvSpPr/>
-          <p:nvPr>
-            <p:ph/>
-          </p:nvPr>
+          <p:cNvPr id="10027" name="TextBox 7"/>
+          <p:cNvSpPr/>
+          <p:nvPr/>
         </p:nvSpPr>
         <p:spPr>
           <a:xfrm xmlns:a="http://schemas.openxmlformats.org/drawingml/2006/main">
@@ -2860,7 +2903,7 @@
           <a:lstStyle xmlns:a="http://schemas.openxmlformats.org/drawingml/2006/main"/>
           <a:p xmlns:a="http://schemas.openxmlformats.org/drawingml/2006/main">
             <a:r>
-              <a:rPr lang="zh-CN" sz="1200">
+              <a:rPr lang="en-US" sz="1200">
                 <a:solidFill>
                   <a:srgbClr val="FFFFFF"/>
                 </a:solidFill>
@@ -2874,11 +2917,9 @@
       </p:sp>
       <p:sp>
         <p:nvSpPr>
-          <p:cNvPr id="9" name="TextBox 8"/>
-          <p:cNvSpPr/>
-          <p:nvPr>
-            <p:ph/>
-          </p:nvPr>
+          <p:cNvPr id="10028" name="TextBox 8"/>
+          <p:cNvSpPr/>
+          <p:nvPr/>
         </p:nvSpPr>
         <p:spPr>
           <a:xfrm xmlns:a="http://schemas.openxmlformats.org/drawingml/2006/main">
@@ -2902,7 +2943,7 @@
           <a:lstStyle xmlns:a="http://schemas.openxmlformats.org/drawingml/2006/main"/>
           <a:p xmlns:a="http://schemas.openxmlformats.org/drawingml/2006/main">
             <a:r>
-              <a:rPr lang="zh-CN" sz="1200">
+              <a:rPr lang="en-US" sz="1200">
                 <a:solidFill>
                   <a:srgbClr val="FFFFFF"/>
                 </a:solidFill>
@@ -2916,11 +2957,9 @@
       </p:sp>
       <p:sp>
         <p:nvSpPr>
-          <p:cNvPr id="10" name="TextBox 9"/>
-          <p:cNvSpPr/>
-          <p:nvPr>
-            <p:ph/>
-          </p:nvPr>
+          <p:cNvPr id="10029" name="TextBox 9"/>
+          <p:cNvSpPr/>
+          <p:nvPr/>
         </p:nvSpPr>
         <p:spPr>
           <a:xfrm xmlns:a="http://schemas.openxmlformats.org/drawingml/2006/main">
@@ -2944,7 +2983,7 @@
           <a:lstStyle xmlns:a="http://schemas.openxmlformats.org/drawingml/2006/main"/>
           <a:p xmlns:a="http://schemas.openxmlformats.org/drawingml/2006/main">
             <a:r>
-              <a:rPr lang="zh-CN" sz="1200">
+              <a:rPr lang="en-US" sz="1200">
                 <a:solidFill>
                   <a:srgbClr val="FFFFFF"/>
                 </a:solidFill>
@@ -2958,11 +2997,9 @@
       </p:sp>
       <p:sp>
         <p:nvSpPr>
-          <p:cNvPr id="11" name="TextBox 10"/>
-          <p:cNvSpPr/>
-          <p:nvPr>
-            <p:ph/>
-          </p:nvPr>
+          <p:cNvPr id="10030" name="TextBox 10"/>
+          <p:cNvSpPr/>
+          <p:nvPr/>
         </p:nvSpPr>
         <p:spPr>
           <a:xfrm xmlns:a="http://schemas.openxmlformats.org/drawingml/2006/main">
@@ -2986,7 +3023,7 @@
           <a:lstStyle xmlns:a="http://schemas.openxmlformats.org/drawingml/2006/main"/>
           <a:p xmlns:a="http://schemas.openxmlformats.org/drawingml/2006/main">
             <a:r>
-              <a:rPr lang="zh-CN" sz="1200">
+              <a:rPr lang="en-US" sz="1200">
                 <a:solidFill>
                   <a:srgbClr val="FFFFFF"/>
                 </a:solidFill>
@@ -3000,11 +3037,9 @@
       </p:sp>
       <p:sp>
         <p:nvSpPr>
-          <p:cNvPr id="12" name="TextBox 11"/>
-          <p:cNvSpPr/>
-          <p:nvPr>
-            <p:ph/>
-          </p:nvPr>
+          <p:cNvPr id="10031" name="TextBox 11"/>
+          <p:cNvSpPr/>
+          <p:nvPr/>
         </p:nvSpPr>
         <p:spPr>
           <a:xfrm xmlns:a="http://schemas.openxmlformats.org/drawingml/2006/main">
@@ -3028,7 +3063,7 @@
           <a:lstStyle xmlns:a="http://schemas.openxmlformats.org/drawingml/2006/main"/>
           <a:p xmlns:a="http://schemas.openxmlformats.org/drawingml/2006/main">
             <a:r>
-              <a:rPr lang="zh-CN" sz="1200">
+              <a:rPr lang="en-US" sz="1200">
                 <a:solidFill>
                   <a:srgbClr val="FFFFFF"/>
                 </a:solidFill>
@@ -3042,11 +3077,9 @@
       </p:sp>
       <p:sp>
         <p:nvSpPr>
-          <p:cNvPr id="13" name="TextBox 12"/>
-          <p:cNvSpPr/>
-          <p:nvPr>
-            <p:ph/>
-          </p:nvPr>
+          <p:cNvPr id="10032" name="TextBox 12"/>
+          <p:cNvSpPr/>
+          <p:nvPr/>
         </p:nvSpPr>
         <p:spPr>
           <a:xfrm xmlns:a="http://schemas.openxmlformats.org/drawingml/2006/main">
@@ -3070,7 +3103,7 @@
           <a:lstStyle xmlns:a="http://schemas.openxmlformats.org/drawingml/2006/main"/>
           <a:p xmlns:a="http://schemas.openxmlformats.org/drawingml/2006/main">
             <a:r>
-              <a:rPr lang="zh-CN" sz="1200">
+              <a:rPr lang="en-US" sz="1200">
                 <a:solidFill>
                   <a:srgbClr val="FFFFFF"/>
                 </a:solidFill>
@@ -3084,11 +3117,9 @@
       </p:sp>
       <p:sp>
         <p:nvSpPr>
-          <p:cNvPr id="14" name="TextBox 13"/>
-          <p:cNvSpPr/>
-          <p:nvPr>
-            <p:ph/>
-          </p:nvPr>
+          <p:cNvPr id="10033" name="TextBox 13"/>
+          <p:cNvSpPr/>
+          <p:nvPr/>
         </p:nvSpPr>
         <p:spPr>
           <a:xfrm xmlns:a="http://schemas.openxmlformats.org/drawingml/2006/main">
@@ -3112,7 +3143,7 @@
           <a:lstStyle xmlns:a="http://schemas.openxmlformats.org/drawingml/2006/main"/>
           <a:p xmlns:a="http://schemas.openxmlformats.org/drawingml/2006/main">
             <a:r>
-              <a:rPr lang="zh-CN" sz="1200">
+              <a:rPr lang="en-US" sz="1200">
                 <a:solidFill>
                   <a:srgbClr val="FFFFFF"/>
                 </a:solidFill>
@@ -3126,11 +3157,9 @@
       </p:sp>
       <p:sp>
         <p:nvSpPr>
-          <p:cNvPr id="15" name="TextBox 14"/>
-          <p:cNvSpPr/>
-          <p:nvPr>
-            <p:ph/>
-          </p:nvPr>
+          <p:cNvPr id="10034" name="TextBox 14"/>
+          <p:cNvSpPr/>
+          <p:nvPr/>
         </p:nvSpPr>
         <p:spPr>
           <a:xfrm xmlns:a="http://schemas.openxmlformats.org/drawingml/2006/main">
@@ -3154,7 +3183,7 @@
           <a:lstStyle xmlns:a="http://schemas.openxmlformats.org/drawingml/2006/main"/>
           <a:p xmlns:a="http://schemas.openxmlformats.org/drawingml/2006/main">
             <a:r>
-              <a:rPr lang="zh-CN" sz="1200">
+              <a:rPr lang="en-US" sz="1200">
                 <a:solidFill>
                   <a:srgbClr val="FFFFFF"/>
                 </a:solidFill>
@@ -3175,7 +3204,7 @@
 </file>
 
 <file path=ppt/slides/slide6.xml><?xml version="1.0" encoding="utf-8"?>
-<p:sld xmlns:p="http://schemas.openxmlformats.org/presentationml/2006/main">
+<p:sld xmlns:p14="http://schemas.microsoft.com/office/powerpoint/2010/main" xmlns:mc="http://schemas.openxmlformats.org/markup-compatibility/2006" xmlns:p="http://schemas.openxmlformats.org/presentationml/2006/main" mc:Ignorable="p14">
   <p:cSld>
     <p:bg>
       <p:bgPr>
@@ -3193,7 +3222,7 @@
       <p:grpSpPr/>
       <p:sp>
         <p:nvSpPr>
-          <p:cNvPr id="1" name="Title"/>
+          <p:cNvPr id="2" name="Title"/>
           <p:cNvSpPr/>
           <p:nvPr>
             <p:ph type="title"/>
@@ -3210,7 +3239,7 @@
           <a:lstStyle xmlns:a="http://schemas.openxmlformats.org/drawingml/2006/main"/>
           <a:p xmlns:a="http://schemas.openxmlformats.org/drawingml/2006/main">
             <a:r>
-              <a:rPr lang="zh-CN" sz="2800">
+              <a:rPr lang="en-US" sz="2800">
                 <a:solidFill>
                   <a:srgbClr val="FFFFFF"/>
                 </a:solidFill>
@@ -3222,11 +3251,9 @@
       </p:sp>
       <p:sp>
         <p:nvSpPr>
-          <p:cNvPr id="3" name="TextBox 2"/>
-          <p:cNvSpPr/>
-          <p:nvPr>
-            <p:ph/>
-          </p:nvPr>
+          <p:cNvPr id="10035" name="TextBox 2"/>
+          <p:cNvSpPr/>
+          <p:nvPr/>
         </p:nvSpPr>
         <p:spPr>
           <a:xfrm xmlns:a="http://schemas.openxmlformats.org/drawingml/2006/main">
@@ -3245,7 +3272,7 @@
           <a:lstStyle xmlns:a="http://schemas.openxmlformats.org/drawingml/2006/main"/>
           <a:p xmlns:a="http://schemas.openxmlformats.org/drawingml/2006/main">
             <a:r>
-              <a:rPr lang="zh-CN" sz="1300">
+              <a:rPr lang="en-US" sz="1300">
                 <a:solidFill>
                   <a:srgbClr val="FFFFFF"/>
                 </a:solidFill>
@@ -3257,7 +3284,7 @@
           </a:p>
           <a:p xmlns:a="http://schemas.openxmlformats.org/drawingml/2006/main">
             <a:r>
-              <a:rPr lang="zh-CN" sz="1300">
+              <a:rPr lang="en-US" sz="1300">
                 <a:solidFill>
                   <a:srgbClr val="FFFFFF"/>
                 </a:solidFill>
@@ -3271,11 +3298,9 @@
       </p:sp>
       <p:sp>
         <p:nvSpPr>
-          <p:cNvPr id="4" name="TextBox 3"/>
-          <p:cNvSpPr/>
-          <p:nvPr>
-            <p:ph/>
-          </p:nvPr>
+          <p:cNvPr id="10036" name="TextBox 3"/>
+          <p:cNvSpPr/>
+          <p:nvPr/>
         </p:nvSpPr>
         <p:spPr>
           <a:xfrm xmlns:a="http://schemas.openxmlformats.org/drawingml/2006/main">
@@ -3294,7 +3319,7 @@
           <a:lstStyle xmlns:a="http://schemas.openxmlformats.org/drawingml/2006/main"/>
           <a:p xmlns:a="http://schemas.openxmlformats.org/drawingml/2006/main">
             <a:r>
-              <a:rPr lang="zh-CN" sz="1300">
+              <a:rPr lang="en-US" sz="1300">
                 <a:solidFill>
                   <a:srgbClr val="FFFFFF"/>
                 </a:solidFill>
@@ -3306,7 +3331,7 @@
           </a:p>
           <a:p xmlns:a="http://schemas.openxmlformats.org/drawingml/2006/main">
             <a:r>
-              <a:rPr lang="zh-CN" sz="1300">
+              <a:rPr lang="en-US" sz="1300">
                 <a:solidFill>
                   <a:srgbClr val="FFFFFF"/>
                 </a:solidFill>
@@ -3320,11 +3345,9 @@
       </p:sp>
       <p:sp>
         <p:nvSpPr>
-          <p:cNvPr id="5" name="TextBox 4"/>
-          <p:cNvSpPr/>
-          <p:nvPr>
-            <p:ph/>
-          </p:nvPr>
+          <p:cNvPr id="10037" name="TextBox 4"/>
+          <p:cNvSpPr/>
+          <p:nvPr/>
         </p:nvSpPr>
         <p:spPr>
           <a:xfrm xmlns:a="http://schemas.openxmlformats.org/drawingml/2006/main">
@@ -3343,7 +3366,7 @@
           <a:lstStyle xmlns:a="http://schemas.openxmlformats.org/drawingml/2006/main"/>
           <a:p xmlns:a="http://schemas.openxmlformats.org/drawingml/2006/main">
             <a:r>
-              <a:rPr lang="zh-CN" sz="1300">
+              <a:rPr lang="en-US" sz="1300">
                 <a:solidFill>
                   <a:srgbClr val="FFFFFF"/>
                 </a:solidFill>
@@ -3355,7 +3378,7 @@
           </a:p>
           <a:p xmlns:a="http://schemas.openxmlformats.org/drawingml/2006/main">
             <a:r>
-              <a:rPr lang="zh-CN" sz="1300">
+              <a:rPr lang="en-US" sz="1300">
                 <a:solidFill>
                   <a:srgbClr val="FFFFFF"/>
                 </a:solidFill>
@@ -3369,11 +3392,9 @@
       </p:sp>
       <p:sp>
         <p:nvSpPr>
-          <p:cNvPr id="6" name="TextBox 5"/>
-          <p:cNvSpPr/>
-          <p:nvPr>
-            <p:ph/>
-          </p:nvPr>
+          <p:cNvPr id="10038" name="TextBox 5"/>
+          <p:cNvSpPr/>
+          <p:nvPr/>
         </p:nvSpPr>
         <p:spPr>
           <a:xfrm xmlns:a="http://schemas.openxmlformats.org/drawingml/2006/main">
@@ -3392,7 +3413,7 @@
           <a:lstStyle xmlns:a="http://schemas.openxmlformats.org/drawingml/2006/main"/>
           <a:p xmlns:a="http://schemas.openxmlformats.org/drawingml/2006/main">
             <a:r>
-              <a:rPr lang="zh-CN" sz="1300">
+              <a:rPr lang="en-US" sz="1300">
                 <a:solidFill>
                   <a:srgbClr val="FFFFFF"/>
                 </a:solidFill>
@@ -3406,11 +3427,9 @@
       </p:sp>
       <p:sp>
         <p:nvSpPr>
-          <p:cNvPr id="7" name="TextBox 6"/>
-          <p:cNvSpPr/>
-          <p:nvPr>
-            <p:ph/>
-          </p:nvPr>
+          <p:cNvPr id="10039" name="TextBox 6"/>
+          <p:cNvSpPr/>
+          <p:nvPr/>
         </p:nvSpPr>
         <p:spPr>
           <a:xfrm xmlns:a="http://schemas.openxmlformats.org/drawingml/2006/main">
@@ -3429,7 +3448,7 @@
           <a:lstStyle xmlns:a="http://schemas.openxmlformats.org/drawingml/2006/main"/>
           <a:p xmlns:a="http://schemas.openxmlformats.org/drawingml/2006/main">
             <a:r>
-              <a:rPr lang="zh-CN" sz="1300">
+              <a:rPr lang="en-US" sz="1300">
                 <a:solidFill>
                   <a:srgbClr val="FFFFFF"/>
                 </a:solidFill>
@@ -3443,9 +3462,18 @@
       </p:sp>
     </p:spTree>
   </p:cSld>
-  <p:transition advTm="5000">
-    <p14:reveal xmlns:p14="http://schemas.microsoft.com/office/powerpoint/2010/main"/>
-  </p:transition>
+  <mc:AlternateContent>
+    <mc:Choice Requires="p14">
+      <p:transition xmlns:p14="http://schemas.microsoft.com/office/powerpoint/2010/main">
+        <p14:reveal/>
+      </p:transition>
+    </mc:Choice>
+    <mc:Fallback>
+      <p:transition>
+        <p:fade/>
+      </p:transition>
+    </mc:Fallback>
+  </mc:AlternateContent>
   <p:timing>
     <p:tnLst>
       <p:par>
@@ -3480,7 +3508,7 @@
                                           </p:stCondLst>
                                         </p:cTn>
                                         <p:tgtEl>
-                                          <p:spTgt spid="3"/>
+                                          <p:spTgt spid="10035"/>
                                         </p:tgtEl>
                                         <p:attrNameLst>
                                           <p:attrName>style.visibility</p:attrName>
@@ -3494,7 +3522,7 @@
                                       <p:cBhvr>
                                         <p:cTn id="5" dur="500"/>
                                         <p:tgtEl>
-                                          <p:spTgt spid="3"/>
+                                          <p:spTgt spid="10035"/>
                                         </p:tgtEl>
                                       </p:cBhvr>
                                     </p:animEffect>
@@ -3508,19 +3536,19 @@
                     </p:cTn>
                   </p:par>
                   <p:par>
-                    <p:cTn id="14" fill="hold">
+                    <p:cTn id="15" fill="hold">
                       <p:stCondLst>
                         <p:cond delay="0"/>
                       </p:stCondLst>
                       <p:childTnLst>
                         <p:par>
-                          <p:cTn id="13" fill="hold">
+                          <p:cTn id="14" fill="hold">
                             <p:stCondLst>
                               <p:cond delay="0"/>
                             </p:stCondLst>
                             <p:childTnLst>
                               <p:par>
-                                <p:cTn id="9" presetID="2" presetClass="entr" presetSubtype="0" fill="hold" grpId="1" nodeType="afterEffect">
+                                <p:cTn id="9" presetID="2" presetClass="entr" presetSubtype="4" fill="hold" grpId="1" nodeType="afterEffect">
                                   <p:stCondLst>
                                     <p:cond delay="0"/>
                                   </p:stCondLst>
@@ -3533,7 +3561,7 @@
                                           </p:stCondLst>
                                         </p:cTn>
                                         <p:tgtEl>
-                                          <p:spTgt spid="4"/>
+                                          <p:spTgt spid="10036"/>
                                         </p:tgtEl>
                                         <p:attrNameLst>
                                           <p:attrName>style.visibility</p:attrName>
@@ -3543,50 +3571,56 @@
                                         <p:strVal val="visible"/>
                                       </p:to>
                                     </p:set>
-                                    <p:animEffect transition="in" filter="fly">
-                                      <p:cBhvr>
-                                        <p:cTn id="11" dur="500"/>
-                                        <p:tgtEl>
-                                          <p:spTgt spid="4"/>
-                                        </p:tgtEl>
-                                      </p:cBhvr>
-                                    </p:animEffect>
+                                    <p:anim calcmode="lin" valueType="num">
+                                      <p:cBhvr additive="base">
+                                        <p:cTn id="13" dur="500" fill="hold"/>
+                                        <p:tgtEl>
+                                          <p:spTgt spid="10036"/>
+                                        </p:tgtEl>
+                                        <p:attrNameLst>
+                                          <p:attrName>ppt_y</p:attrName>
+                                        </p:attrNameLst>
+                                      </p:cBhvr>
+                                      <p:tavLst>
+                                        <p:tav tm="0">
+                                          <p:val>
+                                            <p:strVal val="1+#ppt_h/2"/>
+                                          </p:val>
+                                        </p:tav>
+                                        <p:tav tm="100000">
+                                          <p:val>
+                                            <p:strVal val="#ppt_y"/>
+                                          </p:val>
+                                        </p:tav>
+                                      </p:tavLst>
+                                    </p:anim>
                                   </p:childTnLst>
                                 </p:cTn>
                               </p:par>
                             </p:childTnLst>
                           </p:cTn>
                         </p:par>
-                      </p:childTnLst>
-                    </p:cTn>
-                  </p:par>
-                  <p:par>
-                    <p:cTn id="20" fill="hold">
-                      <p:stCondLst>
-                        <p:cond delay="0"/>
-                      </p:stCondLst>
-                      <p:childTnLst>
                         <p:par>
-                          <p:cTn id="19" fill="hold">
+                          <p:cTn id="20" fill="hold">
                             <p:stCondLst>
                               <p:cond delay="0"/>
                             </p:stCondLst>
                             <p:childTnLst>
                               <p:par>
-                                <p:cTn id="15" presetID="21" presetClass="entr" presetSubtype="0" fill="hold" grpId="2" nodeType="withEffect">
+                                <p:cTn id="16" presetID="21" presetClass="entr" presetSubtype="0" fill="hold" grpId="2" nodeType="withEffect">
                                   <p:stCondLst>
                                     <p:cond delay="0"/>
                                   </p:stCondLst>
                                   <p:childTnLst>
                                     <p:set>
                                       <p:cBhvr>
-                                        <p:cTn id="16" dur="1" fill="hold">
+                                        <p:cTn id="17" dur="1" fill="hold">
                                           <p:stCondLst>
                                             <p:cond delay="0"/>
                                           </p:stCondLst>
                                         </p:cTn>
                                         <p:tgtEl>
-                                          <p:spTgt spid="5"/>
+                                          <p:spTgt spid="10037"/>
                                         </p:tgtEl>
                                         <p:attrNameLst>
                                           <p:attrName>style.visibility</p:attrName>
@@ -3596,14 +3630,16 @@
                                         <p:strVal val="visible"/>
                                       </p:to>
                                     </p:set>
-                                    <p:animEffect transition="in" filter="zoom">
-                                      <p:cBhvr>
-                                        <p:cTn id="17" dur="500"/>
-                                        <p:tgtEl>
-                                          <p:spTgt spid="5"/>
-                                        </p:tgtEl>
-                                      </p:cBhvr>
-                                    </p:animEffect>
+                                    <p:animScale zoomContents="1">
+                                      <p:cBhvr>
+                                        <p:cTn id="18" dur="500" fill="hold"/>
+                                        <p:tgtEl>
+                                          <p:spTgt spid="10037"/>
+                                        </p:tgtEl>
+                                      </p:cBhvr>
+                                      <p:from x="0" y="0"/>
+                                      <p:to x="100000" y="100000"/>
+                                    </p:animScale>
                                   </p:childTnLst>
                                 </p:cTn>
                               </p:par>
@@ -3616,7 +3652,7 @@
                   <p:par>
                     <p:cTn id="26" fill="hold">
                       <p:stCondLst>
-                        <p:cond delay="indefinite"/>
+                        <p:cond delay="0"/>
                       </p:stCondLst>
                       <p:childTnLst>
                         <p:par>
@@ -3626,7 +3662,7 @@
                             </p:stCondLst>
                             <p:childTnLst>
                               <p:par>
-                                <p:cTn id="21" presetID="20" presetClass="entr" presetSubtype="0" fill="hold" grpId="3" nodeType="clickEffect">
+                                <p:cTn id="21" presetID="20" presetClass="entr" presetSubtype="1" fill="hold" grpId="3" nodeType="afterEffect">
                                   <p:stCondLst>
                                     <p:cond delay="0"/>
                                   </p:stCondLst>
@@ -3639,7 +3675,7 @@
                                           </p:stCondLst>
                                         </p:cTn>
                                         <p:tgtEl>
-                                          <p:spTgt spid="6"/>
+                                          <p:spTgt spid="10038"/>
                                         </p:tgtEl>
                                         <p:attrNameLst>
                                           <p:attrName>style.visibility</p:attrName>
@@ -3653,7 +3689,7 @@
                                       <p:cBhvr>
                                         <p:cTn id="23" dur="2000"/>
                                         <p:tgtEl>
-                                          <p:spTgt spid="6"/>
+                                          <p:spTgt spid="10038"/>
                                         </p:tgtEl>
                                       </p:cBhvr>
                                     </p:animEffect>
@@ -3669,7 +3705,7 @@
                   <p:par>
                     <p:cTn id="32" fill="hold">
                       <p:stCondLst>
-                        <p:cond delay="indefinite"/>
+                        <p:cond delay="0"/>
                       </p:stCondLst>
                       <p:childTnLst>
                         <p:par>
@@ -3679,7 +3715,7 @@
                             </p:stCondLst>
                             <p:childTnLst>
                               <p:par>
-                                <p:cTn id="27" presetID="20" presetClass="entr" presetSubtype="0" fill="hold" grpId="4" nodeType="clickEffect">
+                                <p:cTn id="27" presetID="20" presetClass="entr" presetSubtype="1" fill="hold" grpId="4" nodeType="afterEffect">
                                   <p:stCondLst>
                                     <p:cond delay="0"/>
                                   </p:stCondLst>
@@ -3692,7 +3728,7 @@
                                           </p:stCondLst>
                                         </p:cTn>
                                         <p:tgtEl>
-                                          <p:spTgt spid="7"/>
+                                          <p:spTgt spid="10039"/>
                                         </p:tgtEl>
                                         <p:attrNameLst>
                                           <p:attrName>style.visibility</p:attrName>
@@ -3706,7 +3742,7 @@
                                       <p:cBhvr>
                                         <p:cTn id="29" dur="200"/>
                                         <p:tgtEl>
-                                          <p:spTgt spid="7"/>
+                                          <p:spTgt spid="10039"/>
                                         </p:tgtEl>
                                       </p:cBhvr>
                                     </p:animEffect>
@@ -3741,13 +3777,14 @@
       </p:par>
     </p:tnLst>
     <p:bldLst>
-      <p:bldP spid="3" grpId="0" build="allAtOnce"/>
-      <p:bldP spid="4" grpId="1" build="allAtOnce"/>
-      <p:bldP spid="5" grpId="2" build="allAtOnce"/>
-      <p:bldP spid="6" grpId="3" build="allAtOnce"/>
-      <p:bldP spid="7" grpId="4" build="allAtOnce"/>
+      <p:bldP spid="10035" grpId="0"/>
+      <p:bldP spid="10036" grpId="1"/>
+      <p:bldP spid="10037" grpId="2"/>
+      <p:bldP spid="10038" grpId="3"/>
+      <p:bldP spid="10039" grpId="4"/>
     </p:bldLst>
   </p:timing>
+  <p:transition advTm="5000"/>
 </p:sld>
 </file>
 

</xml_diff>